<commit_message>
Rewrite the ERA5 slides around the result that actually held up
Concatenation failed, the features were redesigned around how the label is
actually defined, and blending probabilities then improved every fold. That
sequence is the finding, so the deck now walks it rather than reporting a
single number: one slide for the three attempts, one for why the redesigned
features work, with the coefficients and single-feature AUCs that show the
southern sub-region and the derived easterly both carrying signal — and the
850 hPa temperature caveat, since the label is seasonal.

Co-Authored-By: Claude Opus 5 <noreply@anthropic.com>
Claude-Session: https://claude.ai/code/session_019nnTfL7acNUTjGfLDvFms9
</commit_message>
<xml_diff>
--- a/reports/進捗報告.pptx
+++ b/reports/進捗報告.pptx
@@ -14,9 +14,10 @@
     <p:sldId id="262" r:id="rId8"/>
     <p:sldId id="263" r:id="rId9"/>
     <p:sldId id="264" r:id="rId10"/>
+    <p:sldId id="265" r:id="rId11"/>
   </p:sldIdLst>
   <p:notesMasterIdLst>
-    <p:notesMasterId r:id="rId11"/>
+    <p:notesMasterId r:id="rId12"/>
   </p:notesMasterIdLst>
   <p:sldSz cx="12192000" cy="6858000"/>
   <p:notesSz cx="6858000" cy="12192000"/>
@@ -537,319 +538,6 @@
 </c:chartSpace>
 </file>
 
-<file path=ppt/charts/chart2.xml><?xml version="1.0" encoding="utf-8"?>
-<c:chartSpace xmlns:c="http://schemas.openxmlformats.org/drawingml/2006/chart" xmlns:a="http://schemas.openxmlformats.org/drawingml/2006/main" xmlns:r="http://schemas.openxmlformats.org/officeDocument/2006/relationships">
-  <c:date1904 val="0"/>
-  <c:roundedCorners val="1"/>
-  <c:chart>
-    <c:title>
-      <c:tx>
-        <c:rich>
-          <a:bodyPr/>
-          <a:lstStyle/>
-          <a:p>
-            <a:pPr>
-              <a:defRPr sz="1200" b="0" i="0" u="none" strike="noStrike">
-                <a:solidFill>
-                  <a:srgbClr val="5A6472"/>
-                </a:solidFill>
-                <a:latin typeface="Arial"/>
-              </a:defRPr>
-            </a:pPr>
-            <a:r>
-              <a:rPr sz="1200" b="0" i="0" u="none" strike="noStrike">
-                <a:solidFill>
-                  <a:srgbClr val="5A6472"/>
-                </a:solidFill>
-                <a:latin typeface="Arial"/>
-              </a:rPr>
-              <a:t>ERA5の数値だけで判別したときの AUC（0.5＝無情報）</a:t>
-            </a:r>
-          </a:p>
-        </c:rich>
-      </c:tx>
-      <c:layout/>
-      <c:overlay val="0"/>
-    </c:title>
-    <c:autoTitleDeleted val="0"/>
-    <c:plotArea>
-      <c:layout/>
-      <c:barChart>
-        <c:barDir val="bar"/>
-        <c:grouping val="clustered"/>
-        <c:varyColors val="0"/>
-        <c:ser>
-          <c:idx val="0"/>
-          <c:order val="0"/>
-          <c:tx>
-            <c:strRef>
-              <c:f>Sheet1!$B$1</c:f>
-              <c:strCache>
-                <c:ptCount val="1"/>
-                <c:pt idx="0">
-                  <c:v>AUC</c:v>
-                </c:pt>
-              </c:strCache>
-            </c:strRef>
-          </c:tx>
-          <c:spPr>
-            <a:solidFill>
-              <a:srgbClr val="1C7293"/>
-            </a:solidFill>
-            <a:effectLst/>
-          </c:spPr>
-          <c:invertIfNegative val="0"/>
-          <c:dLbls>
-            <c:numFmt formatCode="#,##0" sourceLinked="0"/>
-            <c:txPr>
-              <a:bodyPr/>
-              <a:lstStyle/>
-              <a:p>
-                <a:pPr>
-                  <a:defRPr b="0" i="0" strike="noStrike" sz="1000" u="none">
-                    <a:solidFill>
-                      <a:srgbClr val="1A1A1A"/>
-                    </a:solidFill>
-                    <a:latin typeface="Arial"/>
-                  </a:defRPr>
-                </a:pPr>
-              </a:p>
-            </c:txPr>
-            <c:showLegendKey val="0"/>
-            <c:showVal val="1"/>
-            <c:showCatName val="0"/>
-            <c:showSerName val="0"/>
-            <c:showPercent val="0"/>
-            <c:showBubbleSize val="0"/>
-            <c:showLeaderLines val="0"/>
-          </c:dLbls>
-          <c:cat>
-            <c:multiLvlStrRef>
-              <c:f>Sheet1!$A$2:$A$11</c:f>
-              <c:multiLvlStrCache>
-                <c:ptCount val="10"/>
-                <c:lvl>
-                  <c:pt idx="0">
-                    <c:v>西高東低</c:v>
-                  </c:pt>
-                  <c:pt idx="1">
-                    <c:v>台風</c:v>
-                  </c:pt>
-                  <c:pt idx="2">
-                    <c:v>太平洋高気圧型</c:v>
-                  </c:pt>
-                  <c:pt idx="3">
-                    <c:v>オホーツク海高気圧</c:v>
-                  </c:pt>
-                  <c:pt idx="4">
-                    <c:v>二つ玉低気圧</c:v>
-                  </c:pt>
-                  <c:pt idx="5">
-                    <c:v>南岸低気圧</c:v>
-                  </c:pt>
-                  <c:pt idx="6">
-                    <c:v>移動性高気圧</c:v>
-                  </c:pt>
-                  <c:pt idx="7">
-                    <c:v>日本海低気圧</c:v>
-                  </c:pt>
-                  <c:pt idx="8">
-                    <c:v>停滞前線</c:v>
-                  </c:pt>
-                  <c:pt idx="9">
-                    <c:v>前線通過</c:v>
-                  </c:pt>
-                </c:lvl>
-              </c:multiLvlStrCache>
-            </c:multiLvlStrRef>
-          </c:cat>
-          <c:val>
-            <c:numRef>
-              <c:f>Sheet1!$B$2:$B$11</c:f>
-              <c:numCache>
-                <c:formatCode>General</c:formatCode>
-                <c:ptCount val="10"/>
-                <c:pt idx="0">
-                  <c:v>0.953</c:v>
-                </c:pt>
-                <c:pt idx="1">
-                  <c:v>0.94</c:v>
-                </c:pt>
-                <c:pt idx="2">
-                  <c:v>0.884</c:v>
-                </c:pt>
-                <c:pt idx="3">
-                  <c:v>0.879</c:v>
-                </c:pt>
-                <c:pt idx="4">
-                  <c:v>0.855</c:v>
-                </c:pt>
-                <c:pt idx="5">
-                  <c:v>0.83</c:v>
-                </c:pt>
-                <c:pt idx="6">
-                  <c:v>0.825</c:v>
-                </c:pt>
-                <c:pt idx="7">
-                  <c:v>0.822</c:v>
-                </c:pt>
-                <c:pt idx="8">
-                  <c:v>0.777</c:v>
-                </c:pt>
-                <c:pt idx="9">
-                  <c:v>0.756</c:v>
-                </c:pt>
-              </c:numCache>
-            </c:numRef>
-          </c:val>
-        </c:ser>
-        <c:dLbls>
-          <c:numFmt formatCode="#,##0" sourceLinked="0"/>
-          <c:txPr>
-            <a:bodyPr/>
-            <a:lstStyle/>
-            <a:p>
-              <a:pPr>
-                <a:defRPr b="0" i="0" strike="noStrike" sz="1000" u="none">
-                  <a:solidFill>
-                    <a:srgbClr val="1A1A1A"/>
-                  </a:solidFill>
-                  <a:latin typeface="Arial"/>
-                </a:defRPr>
-              </a:pPr>
-            </a:p>
-          </c:txPr>
-          <c:showLegendKey val="0"/>
-          <c:showVal val="1"/>
-          <c:showCatName val="0"/>
-          <c:showSerName val="0"/>
-          <c:showPercent val="0"/>
-          <c:showBubbleSize val="0"/>
-          <c:showLeaderLines val="0"/>
-        </c:dLbls>
-        <c:gapWidth val="150"/>
-        <c:overlap val="0"/>
-        <c:axId val="2094734554"/>
-        <c:axId val="2094734552"/>
-        <c:axId val="2094734556"/>
-      </c:barChart>
-      <c:catAx>
-        <c:axId val="2094734554"/>
-        <c:scaling>
-          <c:orientation val="minMax"/>
-        </c:scaling>
-        <c:delete val="0"/>
-        <c:axPos val="l"/>
-        <c:numFmt formatCode="General" sourceLinked="1"/>
-        <c:majorTickMark val="out"/>
-        <c:minorTickMark val="none"/>
-        <c:tickLblPos val="nextTo"/>
-        <c:spPr>
-          <a:ln w="12700" cap="flat">
-            <a:solidFill>
-              <a:srgbClr val="888888"/>
-            </a:solidFill>
-            <a:prstDash val="solid"/>
-            <a:round/>
-          </a:ln>
-        </c:spPr>
-        <c:txPr>
-          <a:bodyPr/>
-          <a:lstStyle/>
-          <a:p>
-            <a:pPr>
-              <a:defRPr sz="1100" b="0" i="0" u="none" strike="noStrike">
-                <a:solidFill>
-                  <a:srgbClr val="1A1A1A"/>
-                </a:solidFill>
-                <a:latin typeface="Arial"/>
-              </a:defRPr>
-            </a:pPr>
-            <a:endParaRPr lang="en-US"/>
-          </a:p>
-        </c:txPr>
-        <c:crossAx val="2094734552"/>
-        <c:crosses val="autoZero"/>
-        <c:auto val="1"/>
-        <c:lblAlgn val="ctr"/>
-        <c:noMultiLvlLbl val="1"/>
-      </c:catAx>
-      <c:valAx>
-        <c:axId val="2094734552"/>
-        <c:scaling>
-          <c:orientation val="minMax"/>
-          <c:max val="1"/>
-          <c:min val="0.5"/>
-        </c:scaling>
-        <c:delete val="0"/>
-        <c:axPos val="b"/>
-        <c:majorGridlines>
-          <c:spPr>
-            <a:ln w="12700" cap="flat">
-              <a:solidFill>
-                <a:srgbClr val="EBEFF2"/>
-              </a:solidFill>
-              <a:prstDash val="solid"/>
-              <a:round/>
-            </a:ln>
-          </c:spPr>
-        </c:majorGridlines>
-        <c:numFmt formatCode="General" sourceLinked="0"/>
-        <c:majorTickMark val="out"/>
-        <c:minorTickMark val="none"/>
-        <c:tickLblPos val="low"/>
-        <c:spPr>
-          <a:ln w="12700" cap="flat">
-            <a:solidFill>
-              <a:srgbClr val="888888"/>
-            </a:solidFill>
-            <a:prstDash val="solid"/>
-            <a:round/>
-          </a:ln>
-        </c:spPr>
-        <c:txPr>
-          <a:bodyPr/>
-          <a:lstStyle/>
-          <a:p>
-            <a:pPr>
-              <a:defRPr sz="1000" b="0" i="0" u="none" strike="noStrike">
-                <a:solidFill>
-                  <a:srgbClr val="5A6472"/>
-                </a:solidFill>
-                <a:latin typeface="Arial"/>
-              </a:defRPr>
-            </a:pPr>
-            <a:endParaRPr lang="en-US"/>
-          </a:p>
-        </c:txPr>
-        <c:crossAx val="2094734554"/>
-        <c:crosses val="autoZero"/>
-        <c:crossBetween val="between"/>
-      </c:valAx>
-      <c:spPr>
-        <a:noFill/>
-        <a:ln>
-          <a:noFill/>
-        </a:ln>
-        <a:effectLst/>
-      </c:spPr>
-    </c:plotArea>
-    <c:plotVisOnly val="1"/>
-    <c:dispBlanksAs val="span"/>
-  </c:chart>
-  <c:spPr>
-    <a:noFill/>
-    <a:ln>
-      <a:noFill/>
-    </a:ln>
-    <a:effectLst/>
-  </c:spPr>
-  <c:externalData r:id="rId1">
-    <c:autoUpdate val="0"/>
-  </c:externalData>
-</c:chartSpace>
-</file>
-
 <file path=ppt/notesMasters/notesMaster1.xml><?xml version="1.0" encoding="utf-8"?>
 <p:notesMaster xmlns:a="http://schemas.openxmlformats.org/drawingml/2006/main" xmlns:r="http://schemas.openxmlformats.org/officeDocument/2006/relationships" xmlns:p="http://schemas.openxmlformats.org/presentationml/2006/main">
   <p:cSld>
@@ -1287,6 +975,94 @@
 </p:notes>
 </file>
 
+<file path=ppt/notesSlides/notesSlide10.xml><?xml version="1.0" encoding="utf-8"?>
+<p:notes xmlns:a="http://schemas.openxmlformats.org/drawingml/2006/main" xmlns:r="http://schemas.openxmlformats.org/officeDocument/2006/relationships" xmlns:p="http://schemas.openxmlformats.org/presentationml/2006/main">
+  <p:cSld>
+    <p:spTree>
+      <p:nvGrpSpPr>
+        <p:cNvPr id="1" name=""/>
+        <p:cNvGrpSpPr/>
+        <p:nvPr/>
+      </p:nvGrpSpPr>
+      <p:grpSpPr>
+        <a:xfrm>
+          <a:off x="0" y="0"/>
+          <a:ext cx="0" cy="0"/>
+          <a:chOff x="0" y="0"/>
+          <a:chExt cx="0" cy="0"/>
+        </a:xfrm>
+      </p:grpSpPr>
+      <p:sp>
+        <p:nvSpPr>
+          <p:cNvPr id="2" name="Slide Image Placeholder 1"/>
+          <p:cNvSpPr>
+            <a:spLocks noGrp="1" noRot="1" noChangeAspect="1"/>
+          </p:cNvSpPr>
+          <p:nvPr>
+            <p:ph type="sldImg"/>
+          </p:nvPr>
+        </p:nvSpPr>
+        <p:spPr/>
+      </p:sp>
+      <p:sp>
+        <p:nvSpPr>
+          <p:cNvPr id="3" name="Notes Placeholder 2"/>
+          <p:cNvSpPr>
+            <a:spLocks noGrp="1"/>
+          </p:cNvSpPr>
+          <p:nvPr>
+            <p:ph type="body" idx="1"/>
+          </p:nvPr>
+        </p:nvSpPr>
+        <p:spPr/>
+        <p:txBody>
+          <a:bodyPr/>
+          <a:lstStyle/>
+          <a:p>
+            <a:r>
+              <a:rPr lang="en-US" dirty="0"/>
+              <a:t>次の5項目。特に2のラベル再現性の測定を優先したい。人間でも判断が揺れるなら、モデルがそれを超えることは原理的にない。上限を知ることで、現在の到達度を初めて評価できる。</a:t>
+            </a:r>
+            <a:endParaRPr lang="en-US" dirty="0"/>
+          </a:p>
+        </p:txBody>
+      </p:sp>
+      <p:sp>
+        <p:nvSpPr>
+          <p:cNvPr id="4" name="Slide Number Placeholder 3"/>
+          <p:cNvSpPr>
+            <a:spLocks noGrp="1"/>
+          </p:cNvSpPr>
+          <p:nvPr>
+            <p:ph type="sldNum" sz="quarter" idx="10"/>
+          </p:nvPr>
+        </p:nvSpPr>
+        <p:spPr/>
+        <p:txBody>
+          <a:bodyPr/>
+          <a:lstStyle/>
+          <a:p>
+            <a:fld id="{F7021451-1387-4CA6-816F-3879F97B5CBC}" type="slidenum">
+              <a:rPr lang="en-US"/>
+              <a:t>10</a:t>
+            </a:fld>
+            <a:endParaRPr lang="en-US"/>
+          </a:p>
+        </p:txBody>
+      </p:sp>
+    </p:spTree>
+    <p:extLst>
+      <p:ext uri="{BB962C8B-B14F-4D97-AF65-F5344CB8AC3E}">
+        <p14:creationId xmlns:p14="http://schemas.microsoft.com/office/powerpoint/2010/main" val="1024086991"/>
+      </p:ext>
+    </p:extLst>
+  </p:cSld>
+  <p:clrMapOvr>
+    <a:masterClrMapping/>
+  </p:clrMapOvr>
+</p:notes>
+</file>
+
 <file path=ppt/notesSlides/notesSlide2.xml><?xml version="1.0" encoding="utf-8"?>
 <p:notes xmlns:a="http://schemas.openxmlformats.org/drawingml/2006/main" xmlns:r="http://schemas.openxmlformats.org/officeDocument/2006/relationships" xmlns:p="http://schemas.openxmlformats.org/presentationml/2006/main">
   <p:cSld>
@@ -1861,7 +1637,7 @@
           <a:p>
             <a:r>
               <a:rPr lang="en-US" dirty="0"/>
-              <a:t>ERA5の格子データから領域ごとの気圧偏差などを計算し、線形モデルで判別できるかを確認した。オホーツク海高気圧でAUC 0.879。情報は存在する。現在これをCNNに統合して交差検証を実施中。</a:t>
+              <a:t>最初は特徴ベクトルに連結したが改善しなかった。次元比が大きく信号が埋もれたと考えられる。特徴量を設計し直し、確率の平均で組み合わせたところ、3つのfoldすべてで改善した。</a:t>
             </a:r>
             <a:endParaRPr lang="en-US" dirty="0"/>
           </a:p>
@@ -1949,7 +1725,7 @@
           <a:p>
             <a:r>
               <a:rPr lang="en-US" dirty="0"/>
-              <a:t>次の5項目。特に2のラベル再現性の測定を優先したい。人間でも判断が揺れるなら、モデルがそれを超えることは原理的にない。上限を知ることで、現在の到達度を初めて評価できる。</a:t>
+              <a:t>ラベルは北東気流が入りそうかという予報官の判断で付けられている。高気圧が海の南部にあるほど入りやすいという知見を、領域の分割と地衡風の計算という形で特徴量にした。単独AUCでも係数でも南が北を上回り、風の係数の符号も判断と一致した。</a:t>
             </a:r>
             <a:endParaRPr lang="en-US" dirty="0"/>
           </a:p>
@@ -2506,6 +2282,876 @@
 </p:sld>
 </file>
 
+<file path=ppt/slides/slide10.xml><?xml version="1.0" encoding="utf-8"?>
+<p:sld xmlns:a="http://schemas.openxmlformats.org/drawingml/2006/main" xmlns:r="http://schemas.openxmlformats.org/officeDocument/2006/relationships" xmlns:p="http://schemas.openxmlformats.org/presentationml/2006/main">
+  <p:cSld name="Slide 10">
+    <p:bg>
+      <p:bgPr>
+        <a:solidFill>
+          <a:srgbClr val="FFFFFF"/>
+        </a:solidFill>
+      </p:bgPr>
+    </p:bg>
+    <p:spTree>
+      <p:nvGrpSpPr>
+        <p:cNvPr id="1" name=""/>
+        <p:cNvGrpSpPr/>
+        <p:nvPr/>
+      </p:nvGrpSpPr>
+      <p:grpSpPr>
+        <a:xfrm>
+          <a:off x="0" y="0"/>
+          <a:ext cx="0" cy="0"/>
+          <a:chOff x="0" y="0"/>
+          <a:chExt cx="0" cy="0"/>
+        </a:xfrm>
+      </p:grpSpPr>
+      <p:sp>
+        <p:nvSpPr>
+          <p:cNvPr id="2" name="Text 0"/>
+          <p:cNvSpPr/>
+          <p:nvPr/>
+        </p:nvSpPr>
+        <p:spPr>
+          <a:xfrm>
+            <a:off x="548640" y="347472"/>
+            <a:ext cx="11064240" cy="274320"/>
+          </a:xfrm>
+          <a:prstGeom prst="rect">
+            <a:avLst/>
+          </a:prstGeom>
+          <a:noFill/>
+          <a:ln/>
+        </p:spPr>
+        <p:txBody>
+          <a:bodyPr wrap="square" rtlCol="0" anchor="ctr"/>
+          <a:lstStyle/>
+          <a:p>
+            <a:pPr indent="0" marL="0">
+              <a:buNone/>
+            </a:pPr>
+            <a:r>
+              <a:rPr lang="en-US" sz="1200" b="1" spc="100" kern="0" dirty="0">
+                <a:solidFill>
+                  <a:srgbClr val="1C7293"/>
+                </a:solidFill>
+                <a:latin typeface="Meiryo" pitchFamily="34" charset="0"/>
+                <a:ea typeface="Meiryo" pitchFamily="34" charset="-122"/>
+                <a:cs typeface="Meiryo" pitchFamily="34" charset="-120"/>
+              </a:rPr>
+              <a:t>次にやること</a:t>
+            </a:r>
+            <a:endParaRPr lang="en-US" sz="1200" dirty="0"/>
+          </a:p>
+        </p:txBody>
+      </p:sp>
+      <p:sp>
+        <p:nvSpPr>
+          <p:cNvPr id="3" name="Text 1"/>
+          <p:cNvSpPr/>
+          <p:nvPr/>
+        </p:nvSpPr>
+        <p:spPr>
+          <a:xfrm>
+            <a:off x="548640" y="621792"/>
+            <a:ext cx="11064240" cy="640080"/>
+          </a:xfrm>
+          <a:prstGeom prst="rect">
+            <a:avLst/>
+          </a:prstGeom>
+          <a:noFill/>
+          <a:ln/>
+        </p:spPr>
+        <p:txBody>
+          <a:bodyPr wrap="square" rtlCol="0" anchor="ctr"/>
+          <a:lstStyle/>
+          <a:p>
+            <a:pPr indent="0" marL="0">
+              <a:buNone/>
+            </a:pPr>
+            <a:r>
+              <a:rPr lang="en-US" sz="3200" b="1" dirty="0">
+                <a:solidFill>
+                  <a:srgbClr val="1A1A1A"/>
+                </a:solidFill>
+                <a:latin typeface="Cambria" pitchFamily="34" charset="0"/>
+                <a:ea typeface="Cambria" pitchFamily="34" charset="-122"/>
+                <a:cs typeface="Cambria" pitchFamily="34" charset="-120"/>
+              </a:rPr>
+              <a:t>今後の課題</a:t>
+            </a:r>
+            <a:endParaRPr lang="en-US" sz="3200" dirty="0"/>
+          </a:p>
+        </p:txBody>
+      </p:sp>
+      <p:sp>
+        <p:nvSpPr>
+          <p:cNvPr id="4" name="Shape 2"/>
+          <p:cNvSpPr/>
+          <p:nvPr/>
+        </p:nvSpPr>
+        <p:spPr>
+          <a:xfrm>
+            <a:off x="640080" y="1636776"/>
+            <a:ext cx="402336" cy="402336"/>
+          </a:xfrm>
+          <a:prstGeom prst="ellipse">
+            <a:avLst/>
+          </a:prstGeom>
+          <a:solidFill>
+            <a:srgbClr val="065A82"/>
+          </a:solidFill>
+          <a:ln/>
+        </p:spPr>
+      </p:sp>
+      <p:sp>
+        <p:nvSpPr>
+          <p:cNvPr id="5" name="Text 3"/>
+          <p:cNvSpPr/>
+          <p:nvPr/>
+        </p:nvSpPr>
+        <p:spPr>
+          <a:xfrm>
+            <a:off x="640080" y="1682496"/>
+            <a:ext cx="402336" cy="310896"/>
+          </a:xfrm>
+          <a:prstGeom prst="rect">
+            <a:avLst/>
+          </a:prstGeom>
+          <a:noFill/>
+          <a:ln/>
+        </p:spPr>
+        <p:txBody>
+          <a:bodyPr wrap="square" lIns="0" tIns="0" rIns="0" bIns="0" rtlCol="0" anchor="ctr"/>
+          <a:lstStyle/>
+          <a:p>
+            <a:pPr algn="ctr" indent="0" marL="0">
+              <a:buNone/>
+            </a:pPr>
+            <a:r>
+              <a:rPr lang="en-US" sz="1400" b="1" dirty="0">
+                <a:solidFill>
+                  <a:srgbClr val="FFFFFF"/>
+                </a:solidFill>
+                <a:latin typeface="Cambria" pitchFamily="34" charset="0"/>
+                <a:ea typeface="Cambria" pitchFamily="34" charset="-122"/>
+                <a:cs typeface="Cambria" pitchFamily="34" charset="-120"/>
+              </a:rPr>
+              <a:t>1</a:t>
+            </a:r>
+            <a:endParaRPr lang="en-US" sz="1400" dirty="0"/>
+          </a:p>
+        </p:txBody>
+      </p:sp>
+      <p:sp>
+        <p:nvSpPr>
+          <p:cNvPr id="6" name="Text 4"/>
+          <p:cNvSpPr/>
+          <p:nvPr/>
+        </p:nvSpPr>
+        <p:spPr>
+          <a:xfrm>
+            <a:off x="1234440" y="1600200"/>
+            <a:ext cx="3931920" cy="365760"/>
+          </a:xfrm>
+          <a:prstGeom prst="rect">
+            <a:avLst/>
+          </a:prstGeom>
+          <a:noFill/>
+          <a:ln/>
+        </p:spPr>
+        <p:txBody>
+          <a:bodyPr wrap="square" lIns="0" tIns="0" rIns="0" bIns="0" rtlCol="0" anchor="ctr"/>
+          <a:lstStyle/>
+          <a:p>
+            <a:pPr indent="0" marL="0">
+              <a:buNone/>
+            </a:pPr>
+            <a:r>
+              <a:rPr lang="en-US" sz="1500" b="1" dirty="0">
+                <a:solidFill>
+                  <a:srgbClr val="1A1A1A"/>
+                </a:solidFill>
+                <a:latin typeface="Meiryo" pitchFamily="34" charset="0"/>
+                <a:ea typeface="Meiryo" pitchFamily="34" charset="-122"/>
+                <a:cs typeface="Meiryo" pitchFamily="34" charset="-120"/>
+              </a:rPr>
+              <a:t>実測の風データの追加</a:t>
+            </a:r>
+            <a:endParaRPr lang="en-US" sz="1500" dirty="0"/>
+          </a:p>
+        </p:txBody>
+      </p:sp>
+      <p:sp>
+        <p:nvSpPr>
+          <p:cNvPr id="7" name="Text 5"/>
+          <p:cNvSpPr/>
+          <p:nvPr/>
+        </p:nvSpPr>
+        <p:spPr>
+          <a:xfrm>
+            <a:off x="5257800" y="1581912"/>
+            <a:ext cx="6309360" cy="566928"/>
+          </a:xfrm>
+          <a:prstGeom prst="rect">
+            <a:avLst/>
+          </a:prstGeom>
+          <a:noFill/>
+          <a:ln/>
+        </p:spPr>
+        <p:txBody>
+          <a:bodyPr wrap="square" lIns="0" tIns="0" rIns="0" bIns="0" rtlCol="0" anchor="ctr"/>
+          <a:lstStyle/>
+          <a:p>
+            <a:pPr indent="0" marL="0">
+              <a:buNone/>
+            </a:pPr>
+            <a:r>
+              <a:rPr lang="en-US" sz="1200" dirty="0">
+                <a:solidFill>
+                  <a:srgbClr val="5A6472"/>
+                </a:solidFill>
+                <a:latin typeface="Meiryo" pitchFamily="34" charset="0"/>
+                <a:ea typeface="Meiryo" pitchFamily="34" charset="-122"/>
+                <a:cs typeface="Meiryo" pitchFamily="34" charset="-120"/>
+              </a:rPr>
+              <a:t>現在は気圧から計算した地衡風。ERA5の風そのものを使えば、摩擦や上層の影響も含められる。</a:t>
+            </a:r>
+            <a:endParaRPr lang="en-US" sz="1200" dirty="0"/>
+          </a:p>
+        </p:txBody>
+      </p:sp>
+      <p:sp>
+        <p:nvSpPr>
+          <p:cNvPr id="8" name="Shape 6"/>
+          <p:cNvSpPr/>
+          <p:nvPr/>
+        </p:nvSpPr>
+        <p:spPr>
+          <a:xfrm>
+            <a:off x="640080" y="2432304"/>
+            <a:ext cx="402336" cy="402336"/>
+          </a:xfrm>
+          <a:prstGeom prst="ellipse">
+            <a:avLst/>
+          </a:prstGeom>
+          <a:solidFill>
+            <a:srgbClr val="B3341F"/>
+          </a:solidFill>
+          <a:ln/>
+        </p:spPr>
+      </p:sp>
+      <p:sp>
+        <p:nvSpPr>
+          <p:cNvPr id="9" name="Text 7"/>
+          <p:cNvSpPr/>
+          <p:nvPr/>
+        </p:nvSpPr>
+        <p:spPr>
+          <a:xfrm>
+            <a:off x="640080" y="2478024"/>
+            <a:ext cx="402336" cy="310896"/>
+          </a:xfrm>
+          <a:prstGeom prst="rect">
+            <a:avLst/>
+          </a:prstGeom>
+          <a:noFill/>
+          <a:ln/>
+        </p:spPr>
+        <p:txBody>
+          <a:bodyPr wrap="square" lIns="0" tIns="0" rIns="0" bIns="0" rtlCol="0" anchor="ctr"/>
+          <a:lstStyle/>
+          <a:p>
+            <a:pPr algn="ctr" indent="0" marL="0">
+              <a:buNone/>
+            </a:pPr>
+            <a:r>
+              <a:rPr lang="en-US" sz="1400" b="1" dirty="0">
+                <a:solidFill>
+                  <a:srgbClr val="FFFFFF"/>
+                </a:solidFill>
+                <a:latin typeface="Cambria" pitchFamily="34" charset="0"/>
+                <a:ea typeface="Cambria" pitchFamily="34" charset="-122"/>
+                <a:cs typeface="Cambria" pitchFamily="34" charset="-120"/>
+              </a:rPr>
+              <a:t>2</a:t>
+            </a:r>
+            <a:endParaRPr lang="en-US" sz="1400" dirty="0"/>
+          </a:p>
+        </p:txBody>
+      </p:sp>
+      <p:sp>
+        <p:nvSpPr>
+          <p:cNvPr id="10" name="Text 8"/>
+          <p:cNvSpPr/>
+          <p:nvPr/>
+        </p:nvSpPr>
+        <p:spPr>
+          <a:xfrm>
+            <a:off x="1234440" y="2395728"/>
+            <a:ext cx="3931920" cy="365760"/>
+          </a:xfrm>
+          <a:prstGeom prst="rect">
+            <a:avLst/>
+          </a:prstGeom>
+          <a:noFill/>
+          <a:ln/>
+        </p:spPr>
+        <p:txBody>
+          <a:bodyPr wrap="square" lIns="0" tIns="0" rIns="0" bIns="0" rtlCol="0" anchor="ctr"/>
+          <a:lstStyle/>
+          <a:p>
+            <a:pPr indent="0" marL="0">
+              <a:buNone/>
+            </a:pPr>
+            <a:r>
+              <a:rPr lang="en-US" sz="1500" b="1" dirty="0">
+                <a:solidFill>
+                  <a:srgbClr val="1A1A1A"/>
+                </a:solidFill>
+                <a:latin typeface="Meiryo" pitchFamily="34" charset="0"/>
+                <a:ea typeface="Meiryo" pitchFamily="34" charset="-122"/>
+                <a:cs typeface="Meiryo" pitchFamily="34" charset="-120"/>
+              </a:rPr>
+              <a:t>ラベルの再現性の測定</a:t>
+            </a:r>
+            <a:endParaRPr lang="en-US" sz="1500" dirty="0"/>
+          </a:p>
+        </p:txBody>
+      </p:sp>
+      <p:sp>
+        <p:nvSpPr>
+          <p:cNvPr id="11" name="Text 9"/>
+          <p:cNvSpPr/>
+          <p:nvPr/>
+        </p:nvSpPr>
+        <p:spPr>
+          <a:xfrm>
+            <a:off x="5257800" y="2377440"/>
+            <a:ext cx="6309360" cy="566928"/>
+          </a:xfrm>
+          <a:prstGeom prst="rect">
+            <a:avLst/>
+          </a:prstGeom>
+          <a:noFill/>
+          <a:ln/>
+        </p:spPr>
+        <p:txBody>
+          <a:bodyPr wrap="square" lIns="0" tIns="0" rIns="0" bIns="0" rtlCol="0" anchor="ctr"/>
+          <a:lstStyle/>
+          <a:p>
+            <a:pPr indent="0" marL="0">
+              <a:buNone/>
+            </a:pPr>
+            <a:r>
+              <a:rPr lang="en-US" sz="1200" dirty="0">
+                <a:solidFill>
+                  <a:srgbClr val="5A6472"/>
+                </a:solidFill>
+                <a:latin typeface="Meiryo" pitchFamily="34" charset="0"/>
+                <a:ea typeface="Meiryo" pitchFamily="34" charset="-122"/>
+                <a:cs typeface="Meiryo" pitchFamily="34" charset="-120"/>
+              </a:rPr>
+              <a:t>同じ天気図に答えを見ずに再度ラベル付けし、人間の判断のゆらぎを測る。これが達成可能な性能の上限になる。</a:t>
+            </a:r>
+            <a:endParaRPr lang="en-US" sz="1200" dirty="0"/>
+          </a:p>
+        </p:txBody>
+      </p:sp>
+      <p:sp>
+        <p:nvSpPr>
+          <p:cNvPr id="12" name="Shape 10"/>
+          <p:cNvSpPr/>
+          <p:nvPr/>
+        </p:nvSpPr>
+        <p:spPr>
+          <a:xfrm>
+            <a:off x="640080" y="3227832"/>
+            <a:ext cx="402336" cy="402336"/>
+          </a:xfrm>
+          <a:prstGeom prst="ellipse">
+            <a:avLst/>
+          </a:prstGeom>
+          <a:solidFill>
+            <a:srgbClr val="065A82"/>
+          </a:solidFill>
+          <a:ln/>
+        </p:spPr>
+      </p:sp>
+      <p:sp>
+        <p:nvSpPr>
+          <p:cNvPr id="13" name="Text 11"/>
+          <p:cNvSpPr/>
+          <p:nvPr/>
+        </p:nvSpPr>
+        <p:spPr>
+          <a:xfrm>
+            <a:off x="640080" y="3273552"/>
+            <a:ext cx="402336" cy="310896"/>
+          </a:xfrm>
+          <a:prstGeom prst="rect">
+            <a:avLst/>
+          </a:prstGeom>
+          <a:noFill/>
+          <a:ln/>
+        </p:spPr>
+        <p:txBody>
+          <a:bodyPr wrap="square" lIns="0" tIns="0" rIns="0" bIns="0" rtlCol="0" anchor="ctr"/>
+          <a:lstStyle/>
+          <a:p>
+            <a:pPr algn="ctr" indent="0" marL="0">
+              <a:buNone/>
+            </a:pPr>
+            <a:r>
+              <a:rPr lang="en-US" sz="1400" b="1" dirty="0">
+                <a:solidFill>
+                  <a:srgbClr val="FFFFFF"/>
+                </a:solidFill>
+                <a:latin typeface="Cambria" pitchFamily="34" charset="0"/>
+                <a:ea typeface="Cambria" pitchFamily="34" charset="-122"/>
+                <a:cs typeface="Cambria" pitchFamily="34" charset="-120"/>
+              </a:rPr>
+              <a:t>3</a:t>
+            </a:r>
+            <a:endParaRPr lang="en-US" sz="1400" dirty="0"/>
+          </a:p>
+        </p:txBody>
+      </p:sp>
+      <p:sp>
+        <p:nvSpPr>
+          <p:cNvPr id="14" name="Text 12"/>
+          <p:cNvSpPr/>
+          <p:nvPr/>
+        </p:nvSpPr>
+        <p:spPr>
+          <a:xfrm>
+            <a:off x="1234440" y="3191256"/>
+            <a:ext cx="3931920" cy="365760"/>
+          </a:xfrm>
+          <a:prstGeom prst="rect">
+            <a:avLst/>
+          </a:prstGeom>
+          <a:noFill/>
+          <a:ln/>
+        </p:spPr>
+        <p:txBody>
+          <a:bodyPr wrap="square" lIns="0" tIns="0" rIns="0" bIns="0" rtlCol="0" anchor="ctr"/>
+          <a:lstStyle/>
+          <a:p>
+            <a:pPr indent="0" marL="0">
+              <a:buNone/>
+            </a:pPr>
+            <a:r>
+              <a:rPr lang="en-US" sz="1500" b="1" dirty="0">
+                <a:solidFill>
+                  <a:srgbClr val="1A1A1A"/>
+                </a:solidFill>
+                <a:latin typeface="Meiryo" pitchFamily="34" charset="0"/>
+                <a:ea typeface="Meiryo" pitchFamily="34" charset="-122"/>
+                <a:cs typeface="Meiryo" pitchFamily="34" charset="-120"/>
+              </a:rPr>
+              <a:t>乱数シードを変えた再現確認</a:t>
+            </a:r>
+            <a:endParaRPr lang="en-US" sz="1500" dirty="0"/>
+          </a:p>
+        </p:txBody>
+      </p:sp>
+      <p:sp>
+        <p:nvSpPr>
+          <p:cNvPr id="15" name="Text 13"/>
+          <p:cNvSpPr/>
+          <p:nvPr/>
+        </p:nvSpPr>
+        <p:spPr>
+          <a:xfrm>
+            <a:off x="5257800" y="3172968"/>
+            <a:ext cx="6309360" cy="566928"/>
+          </a:xfrm>
+          <a:prstGeom prst="rect">
+            <a:avLst/>
+          </a:prstGeom>
+          <a:noFill/>
+          <a:ln/>
+        </p:spPr>
+        <p:txBody>
+          <a:bodyPr wrap="square" lIns="0" tIns="0" rIns="0" bIns="0" rtlCol="0" anchor="ctr"/>
+          <a:lstStyle/>
+          <a:p>
+            <a:pPr indent="0" marL="0">
+              <a:buNone/>
+            </a:pPr>
+            <a:r>
+              <a:rPr lang="en-US" sz="1200" dirty="0">
+                <a:solidFill>
+                  <a:srgbClr val="5A6472"/>
+                </a:solidFill>
+                <a:latin typeface="Meiryo" pitchFamily="34" charset="0"/>
+                <a:ea typeface="Meiryo" pitchFamily="34" charset="-122"/>
+                <a:cs typeface="Meiryo" pitchFamily="34" charset="-120"/>
+              </a:rPr>
+              <a:t>現在の +0.017 という改善は1条件のみの結果。複数回繰り返して安定性を確認する。</a:t>
+            </a:r>
+            <a:endParaRPr lang="en-US" sz="1200" dirty="0"/>
+          </a:p>
+        </p:txBody>
+      </p:sp>
+      <p:sp>
+        <p:nvSpPr>
+          <p:cNvPr id="16" name="Shape 14"/>
+          <p:cNvSpPr/>
+          <p:nvPr/>
+        </p:nvSpPr>
+        <p:spPr>
+          <a:xfrm>
+            <a:off x="640080" y="4023360"/>
+            <a:ext cx="402336" cy="402336"/>
+          </a:xfrm>
+          <a:prstGeom prst="ellipse">
+            <a:avLst/>
+          </a:prstGeom>
+          <a:solidFill>
+            <a:srgbClr val="065A82"/>
+          </a:solidFill>
+          <a:ln/>
+        </p:spPr>
+      </p:sp>
+      <p:sp>
+        <p:nvSpPr>
+          <p:cNvPr id="17" name="Text 15"/>
+          <p:cNvSpPr/>
+          <p:nvPr/>
+        </p:nvSpPr>
+        <p:spPr>
+          <a:xfrm>
+            <a:off x="640080" y="4069080"/>
+            <a:ext cx="402336" cy="310896"/>
+          </a:xfrm>
+          <a:prstGeom prst="rect">
+            <a:avLst/>
+          </a:prstGeom>
+          <a:noFill/>
+          <a:ln/>
+        </p:spPr>
+        <p:txBody>
+          <a:bodyPr wrap="square" lIns="0" tIns="0" rIns="0" bIns="0" rtlCol="0" anchor="ctr"/>
+          <a:lstStyle/>
+          <a:p>
+            <a:pPr algn="ctr" indent="0" marL="0">
+              <a:buNone/>
+            </a:pPr>
+            <a:r>
+              <a:rPr lang="en-US" sz="1400" b="1" dirty="0">
+                <a:solidFill>
+                  <a:srgbClr val="FFFFFF"/>
+                </a:solidFill>
+                <a:latin typeface="Cambria" pitchFamily="34" charset="0"/>
+                <a:ea typeface="Cambria" pitchFamily="34" charset="-122"/>
+                <a:cs typeface="Cambria" pitchFamily="34" charset="-120"/>
+              </a:rPr>
+              <a:t>4</a:t>
+            </a:r>
+            <a:endParaRPr lang="en-US" sz="1400" dirty="0"/>
+          </a:p>
+        </p:txBody>
+      </p:sp>
+      <p:sp>
+        <p:nvSpPr>
+          <p:cNvPr id="18" name="Text 16"/>
+          <p:cNvSpPr/>
+          <p:nvPr/>
+        </p:nvSpPr>
+        <p:spPr>
+          <a:xfrm>
+            <a:off x="1234440" y="3986784"/>
+            <a:ext cx="3931920" cy="365760"/>
+          </a:xfrm>
+          <a:prstGeom prst="rect">
+            <a:avLst/>
+          </a:prstGeom>
+          <a:noFill/>
+          <a:ln/>
+        </p:spPr>
+        <p:txBody>
+          <a:bodyPr wrap="square" lIns="0" tIns="0" rIns="0" bIns="0" rtlCol="0" anchor="ctr"/>
+          <a:lstStyle/>
+          <a:p>
+            <a:pPr indent="0" marL="0">
+              <a:buNone/>
+            </a:pPr>
+            <a:r>
+              <a:rPr lang="en-US" sz="1500" b="1" dirty="0">
+                <a:solidFill>
+                  <a:srgbClr val="1A1A1A"/>
+                </a:solidFill>
+                <a:latin typeface="Meiryo" pitchFamily="34" charset="0"/>
+                <a:ea typeface="Meiryo" pitchFamily="34" charset="-122"/>
+                <a:cs typeface="Meiryo" pitchFamily="34" charset="-120"/>
+              </a:rPr>
+              <a:t>確信度の較正</a:t>
+            </a:r>
+            <a:endParaRPr lang="en-US" sz="1500" dirty="0"/>
+          </a:p>
+        </p:txBody>
+      </p:sp>
+      <p:sp>
+        <p:nvSpPr>
+          <p:cNvPr id="19" name="Text 17"/>
+          <p:cNvSpPr/>
+          <p:nvPr/>
+        </p:nvSpPr>
+        <p:spPr>
+          <a:xfrm>
+            <a:off x="5257800" y="3968496"/>
+            <a:ext cx="6309360" cy="566928"/>
+          </a:xfrm>
+          <a:prstGeom prst="rect">
+            <a:avLst/>
+          </a:prstGeom>
+          <a:noFill/>
+          <a:ln/>
+        </p:spPr>
+        <p:txBody>
+          <a:bodyPr wrap="square" lIns="0" tIns="0" rIns="0" bIns="0" rtlCol="0" anchor="ctr"/>
+          <a:lstStyle/>
+          <a:p>
+            <a:pPr indent="0" marL="0">
+              <a:buNone/>
+            </a:pPr>
+            <a:r>
+              <a:rPr lang="en-US" sz="1200" dirty="0">
+                <a:solidFill>
+                  <a:srgbClr val="5A6472"/>
+                </a:solidFill>
+                <a:latin typeface="Meiryo" pitchFamily="34" charset="0"/>
+                <a:ea typeface="Meiryo" pitchFamily="34" charset="-122"/>
+                <a:cs typeface="Meiryo" pitchFamily="34" charset="-120"/>
+              </a:rPr>
+              <a:t>確信度の中央値0.977に対し実際の性能は0.613。自信過剰であり、補正が必要。</a:t>
+            </a:r>
+            <a:endParaRPr lang="en-US" sz="1200" dirty="0"/>
+          </a:p>
+        </p:txBody>
+      </p:sp>
+      <p:sp>
+        <p:nvSpPr>
+          <p:cNvPr id="20" name="Shape 18"/>
+          <p:cNvSpPr/>
+          <p:nvPr/>
+        </p:nvSpPr>
+        <p:spPr>
+          <a:xfrm>
+            <a:off x="640080" y="4818888"/>
+            <a:ext cx="402336" cy="402336"/>
+          </a:xfrm>
+          <a:prstGeom prst="ellipse">
+            <a:avLst/>
+          </a:prstGeom>
+          <a:solidFill>
+            <a:srgbClr val="1C7293"/>
+          </a:solidFill>
+          <a:ln/>
+        </p:spPr>
+      </p:sp>
+      <p:sp>
+        <p:nvSpPr>
+          <p:cNvPr id="21" name="Text 19"/>
+          <p:cNvSpPr/>
+          <p:nvPr/>
+        </p:nvSpPr>
+        <p:spPr>
+          <a:xfrm>
+            <a:off x="640080" y="4864608"/>
+            <a:ext cx="402336" cy="310896"/>
+          </a:xfrm>
+          <a:prstGeom prst="rect">
+            <a:avLst/>
+          </a:prstGeom>
+          <a:noFill/>
+          <a:ln/>
+        </p:spPr>
+        <p:txBody>
+          <a:bodyPr wrap="square" lIns="0" tIns="0" rIns="0" bIns="0" rtlCol="0" anchor="ctr"/>
+          <a:lstStyle/>
+          <a:p>
+            <a:pPr algn="ctr" indent="0" marL="0">
+              <a:buNone/>
+            </a:pPr>
+            <a:r>
+              <a:rPr lang="en-US" sz="1400" b="1" dirty="0">
+                <a:solidFill>
+                  <a:srgbClr val="FFFFFF"/>
+                </a:solidFill>
+                <a:latin typeface="Cambria" pitchFamily="34" charset="0"/>
+                <a:ea typeface="Cambria" pitchFamily="34" charset="-122"/>
+                <a:cs typeface="Cambria" pitchFamily="34" charset="-120"/>
+              </a:rPr>
+              <a:t>5</a:t>
+            </a:r>
+            <a:endParaRPr lang="en-US" sz="1400" dirty="0"/>
+          </a:p>
+        </p:txBody>
+      </p:sp>
+      <p:sp>
+        <p:nvSpPr>
+          <p:cNvPr id="22" name="Text 20"/>
+          <p:cNvSpPr/>
+          <p:nvPr/>
+        </p:nvSpPr>
+        <p:spPr>
+          <a:xfrm>
+            <a:off x="1234440" y="4782312"/>
+            <a:ext cx="3931920" cy="365760"/>
+          </a:xfrm>
+          <a:prstGeom prst="rect">
+            <a:avLst/>
+          </a:prstGeom>
+          <a:noFill/>
+          <a:ln/>
+        </p:spPr>
+        <p:txBody>
+          <a:bodyPr wrap="square" lIns="0" tIns="0" rIns="0" bIns="0" rtlCol="0" anchor="ctr"/>
+          <a:lstStyle/>
+          <a:p>
+            <a:pPr indent="0" marL="0">
+              <a:buNone/>
+            </a:pPr>
+            <a:r>
+              <a:rPr lang="en-US" sz="1500" b="1" dirty="0">
+                <a:solidFill>
+                  <a:srgbClr val="1A1A1A"/>
+                </a:solidFill>
+                <a:latin typeface="Meiryo" pitchFamily="34" charset="0"/>
+                <a:ea typeface="Meiryo" pitchFamily="34" charset="-122"/>
+                <a:cs typeface="Meiryo" pitchFamily="34" charset="-120"/>
+              </a:rPr>
+              <a:t>時間方向の情報の利用</a:t>
+            </a:r>
+            <a:endParaRPr lang="en-US" sz="1500" dirty="0"/>
+          </a:p>
+        </p:txBody>
+      </p:sp>
+      <p:sp>
+        <p:nvSpPr>
+          <p:cNvPr id="23" name="Text 21"/>
+          <p:cNvSpPr/>
+          <p:nvPr/>
+        </p:nvSpPr>
+        <p:spPr>
+          <a:xfrm>
+            <a:off x="5257800" y="4764024"/>
+            <a:ext cx="6309360" cy="566928"/>
+          </a:xfrm>
+          <a:prstGeom prst="rect">
+            <a:avLst/>
+          </a:prstGeom>
+          <a:noFill/>
+          <a:ln/>
+        </p:spPr>
+        <p:txBody>
+          <a:bodyPr wrap="square" lIns="0" tIns="0" rIns="0" bIns="0" rtlCol="0" anchor="ctr"/>
+          <a:lstStyle/>
+          <a:p>
+            <a:pPr indent="0" marL="0">
+              <a:buNone/>
+            </a:pPr>
+            <a:r>
+              <a:rPr lang="en-US" sz="1200" dirty="0">
+                <a:solidFill>
+                  <a:srgbClr val="5A6472"/>
+                </a:solidFill>
+                <a:latin typeface="Meiryo" pitchFamily="34" charset="0"/>
+                <a:ea typeface="Meiryo" pitchFamily="34" charset="-122"/>
+                <a:cs typeface="Meiryo" pitchFamily="34" charset="-120"/>
+              </a:rPr>
+              <a:t>「前線通過」「停滞」、および「北東気流が入りそう」という予測は、単一時刻では原理的に判別できない。</a:t>
+            </a:r>
+            <a:endParaRPr lang="en-US" sz="1200" dirty="0"/>
+          </a:p>
+        </p:txBody>
+      </p:sp>
+      <p:sp>
+        <p:nvSpPr>
+          <p:cNvPr id="24" name="Shape 22"/>
+          <p:cNvSpPr/>
+          <p:nvPr/>
+        </p:nvSpPr>
+        <p:spPr>
+          <a:xfrm>
+            <a:off x="640080" y="5623560"/>
+            <a:ext cx="10972800" cy="868680"/>
+          </a:xfrm>
+          <a:prstGeom prst="roundRect">
+            <a:avLst>
+              <a:gd name="adj" fmla="val 8421"/>
+            </a:avLst>
+          </a:prstGeom>
+          <a:solidFill>
+            <a:srgbClr val="F4F7F9"/>
+          </a:solidFill>
+          <a:ln/>
+        </p:spPr>
+      </p:sp>
+      <p:sp>
+        <p:nvSpPr>
+          <p:cNvPr id="25" name="Text 23"/>
+          <p:cNvSpPr/>
+          <p:nvPr/>
+        </p:nvSpPr>
+        <p:spPr>
+          <a:xfrm>
+            <a:off x="914400" y="5833872"/>
+            <a:ext cx="10424160" cy="457200"/>
+          </a:xfrm>
+          <a:prstGeom prst="rect">
+            <a:avLst/>
+          </a:prstGeom>
+          <a:noFill/>
+          <a:ln/>
+        </p:spPr>
+        <p:txBody>
+          <a:bodyPr wrap="square" lIns="0" tIns="0" rIns="0" bIns="0" rtlCol="0" anchor="ctr"/>
+          <a:lstStyle/>
+          <a:p>
+            <a:pPr indent="0" marL="0">
+              <a:buNone/>
+            </a:pPr>
+            <a:r>
+              <a:rPr lang="en-US" sz="1350" b="1" dirty="0">
+                <a:solidFill>
+                  <a:srgbClr val="B3341F"/>
+                </a:solidFill>
+                <a:latin typeface="Meiryo" pitchFamily="34" charset="0"/>
+                <a:ea typeface="Meiryo" pitchFamily="34" charset="-122"/>
+                <a:cs typeface="Meiryo" pitchFamily="34" charset="-120"/>
+              </a:rPr>
+              <a:t>優先度が最も高いのは 2 。</a:t>
+            </a:r>
+            <a:pPr indent="0" marL="0">
+              <a:buNone/>
+            </a:pPr>
+            <a:r>
+              <a:rPr lang="en-US" sz="1250" dirty="0">
+                <a:solidFill>
+                  <a:srgbClr val="1A1A1A"/>
+                </a:solidFill>
+                <a:latin typeface="Meiryo" pitchFamily="34" charset="0"/>
+                <a:ea typeface="Meiryo" pitchFamily="34" charset="-122"/>
+                <a:cs typeface="Meiryo" pitchFamily="34" charset="-120"/>
+              </a:rPr>
+              <a:t>　人間の一致率が分からなければ、0.63 という数値が良いのか悪いのかを判断できない。</a:t>
+            </a:r>
+            <a:endParaRPr lang="en-US" sz="1350" dirty="0"/>
+          </a:p>
+        </p:txBody>
+      </p:sp>
+    </p:spTree>
+  </p:cSld>
+  <p:clrMapOvr>
+    <a:masterClrMapping/>
+  </p:clrMapOvr>
+</p:sld>
+</file>
+
 <file path=ppt/slides/slide2.xml><?xml version="1.0" encoding="utf-8"?>
 <p:sld xmlns:a="http://schemas.openxmlformats.org/drawingml/2006/main" xmlns:r="http://schemas.openxmlformats.org/officeDocument/2006/relationships" xmlns:p="http://schemas.openxmlformats.org/presentationml/2006/main">
   <p:cSld name="Slide 2">
@@ -7489,7 +8135,7 @@
                 <a:ea typeface="Meiryo" pitchFamily="34" charset="-122"/>
                 <a:cs typeface="Meiryo" pitchFamily="34" charset="-120"/>
               </a:rPr>
-              <a:t>進行中の改善</a:t>
+              <a:t>改善の試み</a:t>
             </a:r>
             <a:endParaRPr lang="en-US" sz="1200" dirty="0"/>
           </a:p>
@@ -7573,54 +8219,97 @@
           </a:p>
         </p:txBody>
       </p:sp>
-      <p:graphicFrame>
-        <p:nvGraphicFramePr>
-          <p:cNvPr id="5" name="Chart 0" descr=""/>
-          <p:cNvGraphicFramePr/>
-          <p:nvPr/>
-        </p:nvGraphicFramePr>
-        <p:xfrm>
-          <a:off x="457200" y="1920240"/>
-          <a:ext cx="6949440" cy="4206240"/>
-        </p:xfrm>
-        <a:graphic xmlns:a="http://schemas.openxmlformats.org/drawingml/2006/main">
-          <a:graphicData uri="http://schemas.openxmlformats.org/drawingml/2006/chart">
-            <c:chart xmlns:c="http://schemas.openxmlformats.org/drawingml/2006/chart" r:id="rId1"/>
-          </a:graphicData>
-        </a:graphic>
-      </p:graphicFrame>
-      <p:sp>
-        <p:nvSpPr>
-          <p:cNvPr id="6" name="Shape 3"/>
-          <p:cNvSpPr/>
-          <p:nvPr/>
-        </p:nvSpPr>
-        <p:spPr>
-          <a:xfrm>
-            <a:off x="7680960" y="1920240"/>
-            <a:ext cx="3977640" cy="1965960"/>
+      <p:sp>
+        <p:nvSpPr>
+          <p:cNvPr id="5" name="Shape 3"/>
+          <p:cNvSpPr/>
+          <p:nvPr/>
+        </p:nvSpPr>
+        <p:spPr>
+          <a:xfrm>
+            <a:off x="548640" y="1965960"/>
+            <a:ext cx="3566160" cy="2514600"/>
           </a:xfrm>
           <a:prstGeom prst="roundRect">
             <a:avLst>
-              <a:gd name="adj" fmla="val 3721"/>
+              <a:gd name="adj" fmla="val 3636"/>
             </a:avLst>
           </a:prstGeom>
           <a:solidFill>
-            <a:srgbClr val="F4F7F9"/>
+            <a:srgbClr val="FDF1EE"/>
           </a:solidFill>
           <a:ln/>
         </p:spPr>
       </p:sp>
       <p:sp>
         <p:nvSpPr>
-          <p:cNvPr id="7" name="Text 4"/>
-          <p:cNvSpPr/>
-          <p:nvPr/>
-        </p:nvSpPr>
-        <p:spPr>
-          <a:xfrm>
-            <a:off x="7863840" y="2084832"/>
-            <a:ext cx="3611880" cy="1645920"/>
+          <p:cNvPr id="6" name="Shape 4"/>
+          <p:cNvSpPr/>
+          <p:nvPr/>
+        </p:nvSpPr>
+        <p:spPr>
+          <a:xfrm>
+            <a:off x="777240" y="2176272"/>
+            <a:ext cx="420624" cy="420624"/>
+          </a:xfrm>
+          <a:prstGeom prst="ellipse">
+            <a:avLst/>
+          </a:prstGeom>
+          <a:solidFill>
+            <a:srgbClr val="B3341F"/>
+          </a:solidFill>
+          <a:ln/>
+        </p:spPr>
+      </p:sp>
+      <p:sp>
+        <p:nvSpPr>
+          <p:cNvPr id="7" name="Text 5"/>
+          <p:cNvSpPr/>
+          <p:nvPr/>
+        </p:nvSpPr>
+        <p:spPr>
+          <a:xfrm>
+            <a:off x="777240" y="2240280"/>
+            <a:ext cx="420624" cy="310896"/>
+          </a:xfrm>
+          <a:prstGeom prst="rect">
+            <a:avLst/>
+          </a:prstGeom>
+          <a:noFill/>
+          <a:ln/>
+        </p:spPr>
+        <p:txBody>
+          <a:bodyPr wrap="square" lIns="0" tIns="0" rIns="0" bIns="0" rtlCol="0" anchor="ctr"/>
+          <a:lstStyle/>
+          <a:p>
+            <a:pPr algn="ctr" indent="0" marL="0">
+              <a:buNone/>
+            </a:pPr>
+            <a:r>
+              <a:rPr lang="en-US" sz="1500" b="1" dirty="0">
+                <a:solidFill>
+                  <a:srgbClr val="FFFFFF"/>
+                </a:solidFill>
+                <a:latin typeface="Cambria" pitchFamily="34" charset="0"/>
+                <a:ea typeface="Cambria" pitchFamily="34" charset="-122"/>
+                <a:cs typeface="Cambria" pitchFamily="34" charset="-120"/>
+              </a:rPr>
+              <a:t>1</a:t>
+            </a:r>
+            <a:endParaRPr lang="en-US" sz="1500" dirty="0"/>
+          </a:p>
+        </p:txBody>
+      </p:sp>
+      <p:sp>
+        <p:nvSpPr>
+          <p:cNvPr id="8" name="Text 6"/>
+          <p:cNvSpPr/>
+          <p:nvPr/>
+        </p:nvSpPr>
+        <p:spPr>
+          <a:xfrm>
+            <a:off x="1325880" y="2231136"/>
+            <a:ext cx="2651760" cy="365760"/>
           </a:xfrm>
           <a:prstGeom prst="rect">
             <a:avLst/>
@@ -7636,19 +8325,79 @@
               <a:buNone/>
             </a:pPr>
             <a:r>
-              <a:rPr lang="en-US" sz="1350" b="1" dirty="0">
+              <a:rPr lang="en-US" sz="1400" b="1" dirty="0">
                 <a:solidFill>
-                  <a:srgbClr val="065A82"/>
+                  <a:srgbClr val="B3341F"/>
                 </a:solidFill>
                 <a:latin typeface="Meiryo" pitchFamily="34" charset="0"/>
                 <a:ea typeface="Meiryo" pitchFamily="34" charset="-122"/>
                 <a:cs typeface="Meiryo" pitchFamily="34" charset="-120"/>
               </a:rPr>
-              <a:t>効いている特徴量が説明できる
-</a:t>
-            </a:r>
-            <a:endParaRPr lang="en-US" sz="1350" dirty="0"/>
-          </a:p>
+              <a:t>特徴量に連結</a:t>
+            </a:r>
+            <a:endParaRPr lang="en-US" sz="1400" dirty="0"/>
+          </a:p>
+        </p:txBody>
+      </p:sp>
+      <p:sp>
+        <p:nvSpPr>
+          <p:cNvPr id="9" name="Text 7"/>
+          <p:cNvSpPr/>
+          <p:nvPr/>
+        </p:nvSpPr>
+        <p:spPr>
+          <a:xfrm>
+            <a:off x="777240" y="2743200"/>
+            <a:ext cx="3108960" cy="566928"/>
+          </a:xfrm>
+          <a:prstGeom prst="rect">
+            <a:avLst/>
+          </a:prstGeom>
+          <a:noFill/>
+          <a:ln/>
+        </p:spPr>
+        <p:txBody>
+          <a:bodyPr wrap="square" lIns="0" tIns="0" rIns="0" bIns="0" rtlCol="0" anchor="ctr"/>
+          <a:lstStyle/>
+          <a:p>
+            <a:pPr indent="0" marL="0">
+              <a:buNone/>
+            </a:pPr>
+            <a:r>
+              <a:rPr lang="en-US" sz="3000" b="1" dirty="0">
+                <a:solidFill>
+                  <a:srgbClr val="B3341F"/>
+                </a:solidFill>
+                <a:latin typeface="Cambria" pitchFamily="34" charset="0"/>
+                <a:ea typeface="Cambria" pitchFamily="34" charset="-122"/>
+                <a:cs typeface="Cambria" pitchFamily="34" charset="-120"/>
+              </a:rPr>
+              <a:t>0.619</a:t>
+            </a:r>
+            <a:endParaRPr lang="en-US" sz="3000" dirty="0"/>
+          </a:p>
+        </p:txBody>
+      </p:sp>
+      <p:sp>
+        <p:nvSpPr>
+          <p:cNvPr id="10" name="Text 8"/>
+          <p:cNvSpPr/>
+          <p:nvPr/>
+        </p:nvSpPr>
+        <p:spPr>
+          <a:xfrm>
+            <a:off x="777240" y="3364992"/>
+            <a:ext cx="3108960" cy="1005840"/>
+          </a:xfrm>
+          <a:prstGeom prst="rect">
+            <a:avLst/>
+          </a:prstGeom>
+          <a:noFill/>
+          <a:ln/>
+        </p:spPr>
+        <p:txBody>
+          <a:bodyPr wrap="square" lIns="0" tIns="0" rIns="0" bIns="0" rtlCol="0" anchor="ctr"/>
+          <a:lstStyle/>
           <a:p>
             <a:pPr indent="0" marL="0">
               <a:buNone/>
@@ -7662,44 +8411,103 @@
                 <a:ea typeface="Meiryo" pitchFamily="34" charset="-122"/>
                 <a:cs typeface="Meiryo" pitchFamily="34" charset="-120"/>
               </a:rPr>
-              <a:t>オホーツク海高気圧の判別に最も寄与したのは、意図して設計した「オホーツク海領域の気圧偏差」だった。CNNと違い、根拠を数値で示せる。</a:t>
-            </a:r>
-            <a:endParaRPr lang="en-US" sz="1350" dirty="0"/>
-          </a:p>
-        </p:txBody>
-      </p:sp>
-      <p:sp>
-        <p:nvSpPr>
-          <p:cNvPr id="8" name="Shape 5"/>
-          <p:cNvSpPr/>
-          <p:nvPr/>
-        </p:nvSpPr>
-        <p:spPr>
-          <a:xfrm>
-            <a:off x="7680960" y="4069080"/>
-            <a:ext cx="3977640" cy="2057400"/>
+              <a:t>画像側1280次元にERA5の17次元を連結。次元比が大きく、数値の信号が埋もれた。改善せず。</a:t>
+            </a:r>
+            <a:endParaRPr lang="en-US" sz="1150" dirty="0"/>
+          </a:p>
+        </p:txBody>
+      </p:sp>
+      <p:sp>
+        <p:nvSpPr>
+          <p:cNvPr id="11" name="Shape 9"/>
+          <p:cNvSpPr/>
+          <p:nvPr/>
+        </p:nvSpPr>
+        <p:spPr>
+          <a:xfrm>
+            <a:off x="4297680" y="1965960"/>
+            <a:ext cx="3566160" cy="2514600"/>
           </a:xfrm>
           <a:prstGeom prst="roundRect">
             <a:avLst>
-              <a:gd name="adj" fmla="val 3556"/>
+              <a:gd name="adj" fmla="val 3636"/>
             </a:avLst>
           </a:prstGeom>
           <a:solidFill>
-            <a:srgbClr val="FDF1EE"/>
+            <a:srgbClr val="F4F7F9"/>
           </a:solidFill>
           <a:ln/>
         </p:spPr>
       </p:sp>
       <p:sp>
         <p:nvSpPr>
-          <p:cNvPr id="9" name="Text 6"/>
-          <p:cNvSpPr/>
-          <p:nvPr/>
-        </p:nvSpPr>
-        <p:spPr>
-          <a:xfrm>
-            <a:off x="7863840" y="4233672"/>
-            <a:ext cx="3611880" cy="1737360"/>
+          <p:cNvPr id="12" name="Shape 10"/>
+          <p:cNvSpPr/>
+          <p:nvPr/>
+        </p:nvSpPr>
+        <p:spPr>
+          <a:xfrm>
+            <a:off x="4526280" y="2176272"/>
+            <a:ext cx="420624" cy="420624"/>
+          </a:xfrm>
+          <a:prstGeom prst="ellipse">
+            <a:avLst/>
+          </a:prstGeom>
+          <a:solidFill>
+            <a:srgbClr val="1C7293"/>
+          </a:solidFill>
+          <a:ln/>
+        </p:spPr>
+      </p:sp>
+      <p:sp>
+        <p:nvSpPr>
+          <p:cNvPr id="13" name="Text 11"/>
+          <p:cNvSpPr/>
+          <p:nvPr/>
+        </p:nvSpPr>
+        <p:spPr>
+          <a:xfrm>
+            <a:off x="4526280" y="2240280"/>
+            <a:ext cx="420624" cy="310896"/>
+          </a:xfrm>
+          <a:prstGeom prst="rect">
+            <a:avLst/>
+          </a:prstGeom>
+          <a:noFill/>
+          <a:ln/>
+        </p:spPr>
+        <p:txBody>
+          <a:bodyPr wrap="square" lIns="0" tIns="0" rIns="0" bIns="0" rtlCol="0" anchor="ctr"/>
+          <a:lstStyle/>
+          <a:p>
+            <a:pPr algn="ctr" indent="0" marL="0">
+              <a:buNone/>
+            </a:pPr>
+            <a:r>
+              <a:rPr lang="en-US" sz="1500" b="1" dirty="0">
+                <a:solidFill>
+                  <a:srgbClr val="FFFFFF"/>
+                </a:solidFill>
+                <a:latin typeface="Cambria" pitchFamily="34" charset="0"/>
+                <a:ea typeface="Cambria" pitchFamily="34" charset="-122"/>
+                <a:cs typeface="Cambria" pitchFamily="34" charset="-120"/>
+              </a:rPr>
+              <a:t>2</a:t>
+            </a:r>
+            <a:endParaRPr lang="en-US" sz="1500" dirty="0"/>
+          </a:p>
+        </p:txBody>
+      </p:sp>
+      <p:sp>
+        <p:nvSpPr>
+          <p:cNvPr id="14" name="Text 12"/>
+          <p:cNvSpPr/>
+          <p:nvPr/>
+        </p:nvSpPr>
+        <p:spPr>
+          <a:xfrm>
+            <a:off x="5074920" y="2231136"/>
+            <a:ext cx="2651760" cy="365760"/>
           </a:xfrm>
           <a:prstGeom prst="rect">
             <a:avLst/>
@@ -7715,19 +8523,79 @@
               <a:buNone/>
             </a:pPr>
             <a:r>
-              <a:rPr lang="en-US" sz="1350" b="1" dirty="0">
+              <a:rPr lang="en-US" sz="1400" b="1" dirty="0">
                 <a:solidFill>
-                  <a:srgbClr val="B3341F"/>
+                  <a:srgbClr val="1C7293"/>
                 </a:solidFill>
                 <a:latin typeface="Meiryo" pitchFamily="34" charset="0"/>
                 <a:ea typeface="Meiryo" pitchFamily="34" charset="-122"/>
                 <a:cs typeface="Meiryo" pitchFamily="34" charset="-120"/>
               </a:rPr>
-              <a:t>注意すべき点
-</a:t>
-            </a:r>
-            <a:endParaRPr lang="en-US" sz="1350" dirty="0"/>
-          </a:p>
+              <a:t>特徴量の再設計</a:t>
+            </a:r>
+            <a:endParaRPr lang="en-US" sz="1400" dirty="0"/>
+          </a:p>
+        </p:txBody>
+      </p:sp>
+      <p:sp>
+        <p:nvSpPr>
+          <p:cNvPr id="15" name="Text 13"/>
+          <p:cNvSpPr/>
+          <p:nvPr/>
+        </p:nvSpPr>
+        <p:spPr>
+          <a:xfrm>
+            <a:off x="4526280" y="2743200"/>
+            <a:ext cx="3108960" cy="566928"/>
+          </a:xfrm>
+          <a:prstGeom prst="rect">
+            <a:avLst/>
+          </a:prstGeom>
+          <a:noFill/>
+          <a:ln/>
+        </p:spPr>
+        <p:txBody>
+          <a:bodyPr wrap="square" lIns="0" tIns="0" rIns="0" bIns="0" rtlCol="0" anchor="ctr"/>
+          <a:lstStyle/>
+          <a:p>
+            <a:pPr indent="0" marL="0">
+              <a:buNone/>
+            </a:pPr>
+            <a:r>
+              <a:rPr lang="en-US" sz="3000" b="1" dirty="0">
+                <a:solidFill>
+                  <a:srgbClr val="1C7293"/>
+                </a:solidFill>
+                <a:latin typeface="Cambria" pitchFamily="34" charset="0"/>
+                <a:ea typeface="Cambria" pitchFamily="34" charset="-122"/>
+                <a:cs typeface="Cambria" pitchFamily="34" charset="-120"/>
+              </a:rPr>
+              <a:t>0.920</a:t>
+            </a:r>
+            <a:endParaRPr lang="en-US" sz="3000" dirty="0"/>
+          </a:p>
+        </p:txBody>
+      </p:sp>
+      <p:sp>
+        <p:nvSpPr>
+          <p:cNvPr id="16" name="Text 14"/>
+          <p:cNvSpPr/>
+          <p:nvPr/>
+        </p:nvSpPr>
+        <p:spPr>
+          <a:xfrm>
+            <a:off x="4526280" y="3364992"/>
+            <a:ext cx="3108960" cy="1005840"/>
+          </a:xfrm>
+          <a:prstGeom prst="rect">
+            <a:avLst/>
+          </a:prstGeom>
+          <a:noFill/>
+          <a:ln/>
+        </p:spPr>
+        <p:txBody>
+          <a:bodyPr wrap="square" lIns="0" tIns="0" rIns="0" bIns="0" rtlCol="0" anchor="ctr"/>
+          <a:lstStyle/>
           <a:p>
             <a:pPr indent="0" marL="0">
               <a:buNone/>
@@ -7741,11 +8609,191 @@
                 <a:ea typeface="Meiryo" pitchFamily="34" charset="-122"/>
                 <a:cs typeface="Meiryo" pitchFamily="34" charset="-120"/>
               </a:rPr>
-              <a:t>・ERA5単独ではCNNに及ばない（0.487 対 0.630）。置き換えではなく補完。
-</a:t>
-            </a:r>
-            <a:endParaRPr lang="en-US" sz="1350" dirty="0"/>
-          </a:p>
+              <a:t>オホーツク海を南北に分割し、地上気圧から北日本の風を計算。ERA5単独のAUCが0.879→0.920に。</a:t>
+            </a:r>
+            <a:endParaRPr lang="en-US" sz="1150" dirty="0"/>
+          </a:p>
+        </p:txBody>
+      </p:sp>
+      <p:sp>
+        <p:nvSpPr>
+          <p:cNvPr id="17" name="Shape 15"/>
+          <p:cNvSpPr/>
+          <p:nvPr/>
+        </p:nvSpPr>
+        <p:spPr>
+          <a:xfrm>
+            <a:off x="8046720" y="1965960"/>
+            <a:ext cx="3566160" cy="2514600"/>
+          </a:xfrm>
+          <a:prstGeom prst="roundRect">
+            <a:avLst>
+              <a:gd name="adj" fmla="val 3636"/>
+            </a:avLst>
+          </a:prstGeom>
+          <a:solidFill>
+            <a:srgbClr val="F4F7F9"/>
+          </a:solidFill>
+          <a:ln/>
+        </p:spPr>
+      </p:sp>
+      <p:sp>
+        <p:nvSpPr>
+          <p:cNvPr id="18" name="Shape 16"/>
+          <p:cNvSpPr/>
+          <p:nvPr/>
+        </p:nvSpPr>
+        <p:spPr>
+          <a:xfrm>
+            <a:off x="8275320" y="2176272"/>
+            <a:ext cx="420624" cy="420624"/>
+          </a:xfrm>
+          <a:prstGeom prst="ellipse">
+            <a:avLst/>
+          </a:prstGeom>
+          <a:solidFill>
+            <a:srgbClr val="065A82"/>
+          </a:solidFill>
+          <a:ln/>
+        </p:spPr>
+      </p:sp>
+      <p:sp>
+        <p:nvSpPr>
+          <p:cNvPr id="19" name="Text 17"/>
+          <p:cNvSpPr/>
+          <p:nvPr/>
+        </p:nvSpPr>
+        <p:spPr>
+          <a:xfrm>
+            <a:off x="8275320" y="2240280"/>
+            <a:ext cx="420624" cy="310896"/>
+          </a:xfrm>
+          <a:prstGeom prst="rect">
+            <a:avLst/>
+          </a:prstGeom>
+          <a:noFill/>
+          <a:ln/>
+        </p:spPr>
+        <p:txBody>
+          <a:bodyPr wrap="square" lIns="0" tIns="0" rIns="0" bIns="0" rtlCol="0" anchor="ctr"/>
+          <a:lstStyle/>
+          <a:p>
+            <a:pPr algn="ctr" indent="0" marL="0">
+              <a:buNone/>
+            </a:pPr>
+            <a:r>
+              <a:rPr lang="en-US" sz="1500" b="1" dirty="0">
+                <a:solidFill>
+                  <a:srgbClr val="FFFFFF"/>
+                </a:solidFill>
+                <a:latin typeface="Cambria" pitchFamily="34" charset="0"/>
+                <a:ea typeface="Cambria" pitchFamily="34" charset="-122"/>
+                <a:cs typeface="Cambria" pitchFamily="34" charset="-120"/>
+              </a:rPr>
+              <a:t>3</a:t>
+            </a:r>
+            <a:endParaRPr lang="en-US" sz="1500" dirty="0"/>
+          </a:p>
+        </p:txBody>
+      </p:sp>
+      <p:sp>
+        <p:nvSpPr>
+          <p:cNvPr id="20" name="Text 18"/>
+          <p:cNvSpPr/>
+          <p:nvPr/>
+        </p:nvSpPr>
+        <p:spPr>
+          <a:xfrm>
+            <a:off x="8823960" y="2231136"/>
+            <a:ext cx="2651760" cy="365760"/>
+          </a:xfrm>
+          <a:prstGeom prst="rect">
+            <a:avLst/>
+          </a:prstGeom>
+          <a:noFill/>
+          <a:ln/>
+        </p:spPr>
+        <p:txBody>
+          <a:bodyPr wrap="square" lIns="0" tIns="0" rIns="0" bIns="0" rtlCol="0" anchor="ctr"/>
+          <a:lstStyle/>
+          <a:p>
+            <a:pPr indent="0" marL="0">
+              <a:buNone/>
+            </a:pPr>
+            <a:r>
+              <a:rPr lang="en-US" sz="1400" b="1" dirty="0">
+                <a:solidFill>
+                  <a:srgbClr val="065A82"/>
+                </a:solidFill>
+                <a:latin typeface="Meiryo" pitchFamily="34" charset="0"/>
+                <a:ea typeface="Meiryo" pitchFamily="34" charset="-122"/>
+                <a:cs typeface="Meiryo" pitchFamily="34" charset="-120"/>
+              </a:rPr>
+              <a:t>確率の平均</a:t>
+            </a:r>
+            <a:endParaRPr lang="en-US" sz="1400" dirty="0"/>
+          </a:p>
+        </p:txBody>
+      </p:sp>
+      <p:sp>
+        <p:nvSpPr>
+          <p:cNvPr id="21" name="Text 19"/>
+          <p:cNvSpPr/>
+          <p:nvPr/>
+        </p:nvSpPr>
+        <p:spPr>
+          <a:xfrm>
+            <a:off x="8275320" y="2743200"/>
+            <a:ext cx="3108960" cy="566928"/>
+          </a:xfrm>
+          <a:prstGeom prst="rect">
+            <a:avLst/>
+          </a:prstGeom>
+          <a:noFill/>
+          <a:ln/>
+        </p:spPr>
+        <p:txBody>
+          <a:bodyPr wrap="square" lIns="0" tIns="0" rIns="0" bIns="0" rtlCol="0" anchor="ctr"/>
+          <a:lstStyle/>
+          <a:p>
+            <a:pPr indent="0" marL="0">
+              <a:buNone/>
+            </a:pPr>
+            <a:r>
+              <a:rPr lang="en-US" sz="3000" b="1" dirty="0">
+                <a:solidFill>
+                  <a:srgbClr val="065A82"/>
+                </a:solidFill>
+                <a:latin typeface="Cambria" pitchFamily="34" charset="0"/>
+                <a:ea typeface="Cambria" pitchFamily="34" charset="-122"/>
+                <a:cs typeface="Cambria" pitchFamily="34" charset="-120"/>
+              </a:rPr>
+              <a:t>0.648</a:t>
+            </a:r>
+            <a:endParaRPr lang="en-US" sz="3000" dirty="0"/>
+          </a:p>
+        </p:txBody>
+      </p:sp>
+      <p:sp>
+        <p:nvSpPr>
+          <p:cNvPr id="22" name="Text 20"/>
+          <p:cNvSpPr/>
+          <p:nvPr/>
+        </p:nvSpPr>
+        <p:spPr>
+          <a:xfrm>
+            <a:off x="8275320" y="3364992"/>
+            <a:ext cx="3108960" cy="1005840"/>
+          </a:xfrm>
+          <a:prstGeom prst="rect">
+            <a:avLst/>
+          </a:prstGeom>
+          <a:noFill/>
+          <a:ln/>
+        </p:spPr>
+        <p:txBody>
+          <a:bodyPr wrap="square" lIns="0" tIns="0" rIns="0" bIns="0" rtlCol="0" anchor="ctr"/>
+          <a:lstStyle/>
           <a:p>
             <a:pPr indent="0" marL="0">
               <a:buNone/>
@@ -7759,9 +8807,88 @@
                 <a:ea typeface="Meiryo" pitchFamily="34" charset="-122"/>
                 <a:cs typeface="Meiryo" pitchFamily="34" charset="-120"/>
               </a:rPr>
-              <a:t>・前線通過だけAUC 0.756と最低。「通過」は時間変化であり、単一時刻の格子には写らない。</a:t>
-            </a:r>
-            <a:endParaRPr lang="en-US" sz="1350" dirty="0"/>
+              <a:t>CNNとERA5を別々に動かし出力確率を混合。3foldすべてで改善（+0.043/+0.005/+0.005）。</a:t>
+            </a:r>
+            <a:endParaRPr lang="en-US" sz="1150" dirty="0"/>
+          </a:p>
+        </p:txBody>
+      </p:sp>
+      <p:sp>
+        <p:nvSpPr>
+          <p:cNvPr id="23" name="Shape 21"/>
+          <p:cNvSpPr/>
+          <p:nvPr/>
+        </p:nvSpPr>
+        <p:spPr>
+          <a:xfrm>
+            <a:off x="548640" y="4709160"/>
+            <a:ext cx="11064240" cy="1234440"/>
+          </a:xfrm>
+          <a:prstGeom prst="roundRect">
+            <a:avLst>
+              <a:gd name="adj" fmla="val 5926"/>
+            </a:avLst>
+          </a:prstGeom>
+          <a:solidFill>
+            <a:srgbClr val="21295C"/>
+          </a:solidFill>
+          <a:ln/>
+        </p:spPr>
+      </p:sp>
+      <p:sp>
+        <p:nvSpPr>
+          <p:cNvPr id="24" name="Text 22"/>
+          <p:cNvSpPr/>
+          <p:nvPr/>
+        </p:nvSpPr>
+        <p:spPr>
+          <a:xfrm>
+            <a:off x="868680" y="4873752"/>
+            <a:ext cx="10424160" cy="914400"/>
+          </a:xfrm>
+          <a:prstGeom prst="rect">
+            <a:avLst/>
+          </a:prstGeom>
+          <a:noFill/>
+          <a:ln/>
+        </p:spPr>
+        <p:txBody>
+          <a:bodyPr wrap="square" lIns="0" tIns="0" rIns="0" bIns="0" rtlCol="0" anchor="ctr"/>
+          <a:lstStyle/>
+          <a:p>
+            <a:pPr indent="0" marL="0">
+              <a:buNone/>
+            </a:pPr>
+            <a:r>
+              <a:rPr lang="en-US" sz="1500" b="1" dirty="0">
+                <a:solidFill>
+                  <a:srgbClr val="FFFFFF"/>
+                </a:solidFill>
+                <a:latin typeface="Meiryo" pitchFamily="34" charset="0"/>
+                <a:ea typeface="Meiryo" pitchFamily="34" charset="-122"/>
+                <a:cs typeface="Meiryo" pitchFamily="34" charset="-120"/>
+              </a:rPr>
+              <a:t>到達点：macro F1  0.613（基本）→ 0.630（座標情報）→ 0.648（ERA5併用）
+</a:t>
+            </a:r>
+            <a:endParaRPr lang="en-US" sz="1500" dirty="0"/>
+          </a:p>
+          <a:p>
+            <a:pPr indent="0" marL="0">
+              <a:buNone/>
+            </a:pPr>
+            <a:r>
+              <a:rPr lang="en-US" sz="1250" dirty="0">
+                <a:solidFill>
+                  <a:srgbClr val="CADCFC"/>
+                </a:solidFill>
+                <a:latin typeface="Meiryo" pitchFamily="34" charset="0"/>
+                <a:ea typeface="Meiryo" pitchFamily="34" charset="-122"/>
+                <a:cs typeface="Meiryo" pitchFamily="34" charset="-120"/>
+              </a:rPr>
+              <a:t>オホーツク海高気圧は 0.155 → 0.240 → 0.297。統合方法の選択が結果を左右した。</a:t>
+            </a:r>
+            <a:endParaRPr lang="en-US" sz="1500" dirty="0"/>
           </a:p>
         </p:txBody>
       </p:sp>
@@ -7830,7 +8957,7 @@
                 <a:ea typeface="Meiryo" pitchFamily="34" charset="-122"/>
                 <a:cs typeface="Meiryo" pitchFamily="34" charset="-120"/>
               </a:rPr>
-              <a:t>次にやること</a:t>
+              <a:t>改善の中身</a:t>
             </a:r>
             <a:endParaRPr lang="en-US" sz="1200" dirty="0"/>
           </a:p>
@@ -7869,7 +8996,7 @@
                 <a:ea typeface="Cambria" pitchFamily="34" charset="-122"/>
                 <a:cs typeface="Cambria" pitchFamily="34" charset="-120"/>
               </a:rPr>
-              <a:t>今後の課題</a:t>
+              <a:t>予報官の判断基準を特徴量にした</a:t>
             </a:r>
             <a:endParaRPr lang="en-US" sz="3200" dirty="0"/>
           </a:p>
@@ -7883,14 +9010,16 @@
         </p:nvSpPr>
         <p:spPr>
           <a:xfrm>
-            <a:off x="640080" y="1636776"/>
-            <a:ext cx="402336" cy="402336"/>
-          </a:xfrm>
-          <a:prstGeom prst="ellipse">
-            <a:avLst/>
+            <a:off x="548640" y="1463040"/>
+            <a:ext cx="11064240" cy="868680"/>
+          </a:xfrm>
+          <a:prstGeom prst="roundRect">
+            <a:avLst>
+              <a:gd name="adj" fmla="val 8421"/>
+            </a:avLst>
           </a:prstGeom>
           <a:solidFill>
-            <a:srgbClr val="065A82"/>
+            <a:srgbClr val="F4F7F9"/>
           </a:solidFill>
           <a:ln/>
         </p:spPr>
@@ -7903,47 +9032,8 @@
         </p:nvSpPr>
         <p:spPr>
           <a:xfrm>
-            <a:off x="640080" y="1682496"/>
-            <a:ext cx="402336" cy="310896"/>
-          </a:xfrm>
-          <a:prstGeom prst="rect">
-            <a:avLst/>
-          </a:prstGeom>
-          <a:noFill/>
-          <a:ln/>
-        </p:spPr>
-        <p:txBody>
-          <a:bodyPr wrap="square" lIns="0" tIns="0" rIns="0" bIns="0" rtlCol="0" anchor="ctr"/>
-          <a:lstStyle/>
-          <a:p>
-            <a:pPr algn="ctr" indent="0" marL="0">
-              <a:buNone/>
-            </a:pPr>
-            <a:r>
-              <a:rPr lang="en-US" sz="1400" b="1" dirty="0">
-                <a:solidFill>
-                  <a:srgbClr val="FFFFFF"/>
-                </a:solidFill>
-                <a:latin typeface="Cambria" pitchFamily="34" charset="0"/>
-                <a:ea typeface="Cambria" pitchFamily="34" charset="-122"/>
-                <a:cs typeface="Cambria" pitchFamily="34" charset="-120"/>
-              </a:rPr>
-              <a:t>1</a:t>
-            </a:r>
-            <a:endParaRPr lang="en-US" sz="1400" dirty="0"/>
-          </a:p>
-        </p:txBody>
-      </p:sp>
-      <p:sp>
-        <p:nvSpPr>
-          <p:cNvPr id="6" name="Text 4"/>
-          <p:cNvSpPr/>
-          <p:nvPr/>
-        </p:nvSpPr>
-        <p:spPr>
-          <a:xfrm>
-            <a:off x="1234440" y="1600200"/>
-            <a:ext cx="3931920" cy="365760"/>
+            <a:off x="822960" y="1664208"/>
+            <a:ext cx="10515600" cy="548640"/>
           </a:xfrm>
           <a:prstGeom prst="rect">
             <a:avLst/>
@@ -7959,7 +9049,21 @@
               <a:buNone/>
             </a:pPr>
             <a:r>
-              <a:rPr lang="en-US" sz="1500" b="1" dirty="0">
+              <a:rPr lang="en-US" sz="1400" b="1" dirty="0">
+                <a:solidFill>
+                  <a:srgbClr val="065A82"/>
+                </a:solidFill>
+                <a:latin typeface="Meiryo" pitchFamily="34" charset="0"/>
+                <a:ea typeface="Meiryo" pitchFamily="34" charset="-122"/>
+                <a:cs typeface="Meiryo" pitchFamily="34" charset="-120"/>
+              </a:rPr>
+              <a:t>ラベルの定義：</a:t>
+            </a:r>
+            <a:pPr indent="0" marL="0">
+              <a:buNone/>
+            </a:pPr>
+            <a:r>
+              <a:rPr lang="en-US" sz="1350" dirty="0">
                 <a:solidFill>
                   <a:srgbClr val="1A1A1A"/>
                 </a:solidFill>
@@ -7967,22 +9071,22 @@
                 <a:ea typeface="Meiryo" pitchFamily="34" charset="-122"/>
                 <a:cs typeface="Meiryo" pitchFamily="34" charset="-120"/>
               </a:rPr>
-              <a:t>ERA5のCNNへの統合</a:t>
-            </a:r>
-            <a:endParaRPr lang="en-US" sz="1500" dirty="0"/>
-          </a:p>
-        </p:txBody>
-      </p:sp>
-      <p:sp>
-        <p:nvSpPr>
-          <p:cNvPr id="7" name="Text 5"/>
-          <p:cNvSpPr/>
-          <p:nvPr/>
-        </p:nvSpPr>
-        <p:spPr>
-          <a:xfrm>
-            <a:off x="5257800" y="1581912"/>
-            <a:ext cx="6309360" cy="566928"/>
+              <a:t>「オホーツク海に高気圧があり、北東気流が北日本に入りそうな場合」——高気圧が海の南部にあれば北東気流が入りやすく、北部にあれば入りにくい。</a:t>
+            </a:r>
+            <a:endParaRPr lang="en-US" sz="1400" dirty="0"/>
+          </a:p>
+        </p:txBody>
+      </p:sp>
+      <p:sp>
+        <p:nvSpPr>
+          <p:cNvPr id="6" name="Text 4"/>
+          <p:cNvSpPr/>
+          <p:nvPr/>
+        </p:nvSpPr>
+        <p:spPr>
+          <a:xfrm>
+            <a:off x="548640" y="2487168"/>
+            <a:ext cx="11064240" cy="320040"/>
           </a:xfrm>
           <a:prstGeom prst="rect">
             <a:avLst/>
@@ -7991,14 +9095,14 @@
           <a:ln/>
         </p:spPr>
         <p:txBody>
-          <a:bodyPr wrap="square" lIns="0" tIns="0" rIns="0" bIns="0" rtlCol="0" anchor="ctr"/>
+          <a:bodyPr wrap="square" rtlCol="0" anchor="ctr"/>
           <a:lstStyle/>
           <a:p>
             <a:pPr indent="0" marL="0">
               <a:buNone/>
             </a:pPr>
             <a:r>
-              <a:rPr lang="en-US" sz="1200" dirty="0">
+              <a:rPr lang="en-US" sz="1300" dirty="0">
                 <a:solidFill>
                   <a:srgbClr val="5A6472"/>
                 </a:solidFill>
@@ -8006,42 +9110,1386 @@
                 <a:ea typeface="Meiryo" pitchFamily="34" charset="-122"/>
                 <a:cs typeface="Meiryo" pitchFamily="34" charset="-120"/>
               </a:rPr>
-              <a:t>実装は完了。交差検証を実施中。オホーツク海高気圧の改善を確認する。</a:t>
-            </a:r>
-            <a:endParaRPr lang="en-US" sz="1200" dirty="0"/>
-          </a:p>
-        </p:txBody>
-      </p:sp>
-      <p:sp>
-        <p:nvSpPr>
-          <p:cNvPr id="8" name="Shape 6"/>
-          <p:cNvSpPr/>
-          <p:nvPr/>
-        </p:nvSpPr>
-        <p:spPr>
-          <a:xfrm>
-            <a:off x="640080" y="2432304"/>
-            <a:ext cx="402336" cy="402336"/>
-          </a:xfrm>
-          <a:prstGeom prst="ellipse">
-            <a:avLst/>
+              <a:t>当初は北緯45〜60度をひとまとめに平均しており、この区別が消えていた。領域を南北に分け、地上気圧から地衡風を計算して加えた。</a:t>
+            </a:r>
+            <a:endParaRPr lang="en-US" sz="1300" dirty="0"/>
+          </a:p>
+        </p:txBody>
+      </p:sp>
+      <p:graphicFrame>
+        <p:nvGraphicFramePr>
+          <p:cNvPr id="10" name="Table 0"/>
+          <p:cNvGraphicFramePr>
+            <a:graphicFrameLocks noGrp="1"/>
+          </p:cNvGraphicFramePr>
+          <p:nvPr>
+            <p:extLst>
+              <p:ext uri="{D42A27DB-BD31-4B8C-83A1-F6EECF244321}">
+                <p14:modId xmlns:p14="http://schemas.microsoft.com/office/powerpoint/2010/main" val="1579011935"/>
+              </p:ext>
+            </p:extLst>
+          </p:nvPr>
+        </p:nvGraphicFramePr>
+        <p:xfrm>
+          <a:off x="548640" y="2926080"/>
+          <a:ext cx="11064240" cy="914400"/>
+        </p:xfrm>
+        <a:graphic>
+          <a:graphicData uri="http://schemas.openxmlformats.org/drawingml/2006/table">
+            <a:tbl>
+              <a:tblPr/>
+              <a:tblGrid>
+                <a:gridCol w="3200400"/>
+                <a:gridCol w="1371600"/>
+                <a:gridCol w="1188720"/>
+                <a:gridCol w="5303520"/>
+              </a:tblGrid>
+              <a:tr h="384048">
+                <a:tc>
+                  <a:txBody>
+                    <a:bodyPr/>
+                    <a:lstStyle/>
+                    <a:p>
+                      <a:pPr indent="0" marL="0">
+                        <a:buNone/>
+                      </a:pPr>
+                      <a:r>
+                        <a:rPr lang="en-US" sz="1250" b="1" dirty="0">
+                          <a:solidFill>
+                            <a:srgbClr val="1A1A1A"/>
+                          </a:solidFill>
+                          <a:latin typeface="Meiryo" pitchFamily="34" charset="0"/>
+                          <a:ea typeface="Meiryo" pitchFamily="34" charset="-122"/>
+                          <a:cs typeface="Meiryo" pitchFamily="34" charset="-120"/>
+                        </a:rPr>
+                        <a:t>特徴量</a:t>
+                      </a:r>
+                      <a:endParaRPr lang="en-US" sz="1250" dirty="0">
+                        <a:latin typeface="Meiryo" charset="0"/>
+                        <a:ea typeface="Meiryo" charset="0"/>
+                        <a:cs typeface="Meiryo" charset="0"/>
+                      </a:endParaRPr>
+                    </a:p>
+                  </a:txBody>
+                  <a:tcPr marL="91440" marR="91440" marT="45720" marB="45720" anchor="ctr">
+                    <a:lnL w="12700" cap="flat" cmpd="sng" algn="ctr">
+                      <a:solidFill>
+                        <a:srgbClr val="E2E8ED"/>
+                      </a:solidFill>
+                      <a:prstDash val="solid"/>
+                      <a:round/>
+                      <a:headEnd type="none" w="med" len="med"/>
+                      <a:tailEnd type="none" w="med" len="med"/>
+                    </a:lnL>
+                    <a:lnR w="12700" cap="flat" cmpd="sng" algn="ctr">
+                      <a:solidFill>
+                        <a:srgbClr val="E2E8ED"/>
+                      </a:solidFill>
+                      <a:prstDash val="solid"/>
+                      <a:round/>
+                      <a:headEnd type="none" w="med" len="med"/>
+                      <a:tailEnd type="none" w="med" len="med"/>
+                    </a:lnR>
+                    <a:lnT w="12700" cap="flat" cmpd="sng" algn="ctr">
+                      <a:solidFill>
+                        <a:srgbClr val="E2E8ED"/>
+                      </a:solidFill>
+                      <a:prstDash val="solid"/>
+                      <a:round/>
+                      <a:headEnd type="none" w="med" len="med"/>
+                      <a:tailEnd type="none" w="med" len="med"/>
+                    </a:lnT>
+                    <a:lnB w="12700" cap="flat" cmpd="sng" algn="ctr">
+                      <a:solidFill>
+                        <a:srgbClr val="E2E8ED"/>
+                      </a:solidFill>
+                      <a:prstDash val="solid"/>
+                      <a:round/>
+                      <a:headEnd type="none" w="med" len="med"/>
+                      <a:tailEnd type="none" w="med" len="med"/>
+                    </a:lnB>
+                  </a:tcPr>
+                </a:tc>
+                <a:tc>
+                  <a:txBody>
+                    <a:bodyPr/>
+                    <a:lstStyle/>
+                    <a:p>
+                      <a:pPr algn="r" indent="0" marL="0">
+                        <a:buNone/>
+                      </a:pPr>
+                      <a:r>
+                        <a:rPr lang="en-US" sz="1250" b="1" dirty="0">
+                          <a:solidFill>
+                            <a:srgbClr val="1A1A1A"/>
+                          </a:solidFill>
+                          <a:latin typeface="Meiryo" pitchFamily="34" charset="0"/>
+                          <a:ea typeface="Meiryo" pitchFamily="34" charset="-122"/>
+                          <a:cs typeface="Meiryo" pitchFamily="34" charset="-120"/>
+                        </a:rPr>
+                        <a:t>単独AUC</a:t>
+                      </a:r>
+                      <a:endParaRPr lang="en-US" sz="1250" dirty="0">
+                        <a:latin typeface="Meiryo" charset="0"/>
+                        <a:ea typeface="Meiryo" charset="0"/>
+                        <a:cs typeface="Meiryo" charset="0"/>
+                      </a:endParaRPr>
+                    </a:p>
+                  </a:txBody>
+                  <a:tcPr marL="91440" marR="91440" marT="45720" marB="45720" anchor="ctr">
+                    <a:lnL w="12700" cap="flat" cmpd="sng" algn="ctr">
+                      <a:solidFill>
+                        <a:srgbClr val="E2E8ED"/>
+                      </a:solidFill>
+                      <a:prstDash val="solid"/>
+                      <a:round/>
+                      <a:headEnd type="none" w="med" len="med"/>
+                      <a:tailEnd type="none" w="med" len="med"/>
+                    </a:lnL>
+                    <a:lnR w="12700" cap="flat" cmpd="sng" algn="ctr">
+                      <a:solidFill>
+                        <a:srgbClr val="E2E8ED"/>
+                      </a:solidFill>
+                      <a:prstDash val="solid"/>
+                      <a:round/>
+                      <a:headEnd type="none" w="med" len="med"/>
+                      <a:tailEnd type="none" w="med" len="med"/>
+                    </a:lnR>
+                    <a:lnT w="12700" cap="flat" cmpd="sng" algn="ctr">
+                      <a:solidFill>
+                        <a:srgbClr val="E2E8ED"/>
+                      </a:solidFill>
+                      <a:prstDash val="solid"/>
+                      <a:round/>
+                      <a:headEnd type="none" w="med" len="med"/>
+                      <a:tailEnd type="none" w="med" len="med"/>
+                    </a:lnT>
+                    <a:lnB w="12700" cap="flat" cmpd="sng" algn="ctr">
+                      <a:solidFill>
+                        <a:srgbClr val="E2E8ED"/>
+                      </a:solidFill>
+                      <a:prstDash val="solid"/>
+                      <a:round/>
+                      <a:headEnd type="none" w="med" len="med"/>
+                      <a:tailEnd type="none" w="med" len="med"/>
+                    </a:lnB>
+                  </a:tcPr>
+                </a:tc>
+                <a:tc>
+                  <a:txBody>
+                    <a:bodyPr/>
+                    <a:lstStyle/>
+                    <a:p>
+                      <a:pPr algn="r" indent="0" marL="0">
+                        <a:buNone/>
+                      </a:pPr>
+                      <a:r>
+                        <a:rPr lang="en-US" sz="1250" b="1" dirty="0">
+                          <a:solidFill>
+                            <a:srgbClr val="1A1A1A"/>
+                          </a:solidFill>
+                          <a:latin typeface="Meiryo" pitchFamily="34" charset="0"/>
+                          <a:ea typeface="Meiryo" pitchFamily="34" charset="-122"/>
+                          <a:cs typeface="Meiryo" pitchFamily="34" charset="-120"/>
+                        </a:rPr>
+                        <a:t>係数</a:t>
+                      </a:r>
+                      <a:endParaRPr lang="en-US" sz="1250" dirty="0">
+                        <a:latin typeface="Meiryo" charset="0"/>
+                        <a:ea typeface="Meiryo" charset="0"/>
+                        <a:cs typeface="Meiryo" charset="0"/>
+                      </a:endParaRPr>
+                    </a:p>
+                  </a:txBody>
+                  <a:tcPr marL="91440" marR="91440" marT="45720" marB="45720" anchor="ctr">
+                    <a:lnL w="12700" cap="flat" cmpd="sng" algn="ctr">
+                      <a:solidFill>
+                        <a:srgbClr val="E2E8ED"/>
+                      </a:solidFill>
+                      <a:prstDash val="solid"/>
+                      <a:round/>
+                      <a:headEnd type="none" w="med" len="med"/>
+                      <a:tailEnd type="none" w="med" len="med"/>
+                    </a:lnL>
+                    <a:lnR w="12700" cap="flat" cmpd="sng" algn="ctr">
+                      <a:solidFill>
+                        <a:srgbClr val="E2E8ED"/>
+                      </a:solidFill>
+                      <a:prstDash val="solid"/>
+                      <a:round/>
+                      <a:headEnd type="none" w="med" len="med"/>
+                      <a:tailEnd type="none" w="med" len="med"/>
+                    </a:lnR>
+                    <a:lnT w="12700" cap="flat" cmpd="sng" algn="ctr">
+                      <a:solidFill>
+                        <a:srgbClr val="E2E8ED"/>
+                      </a:solidFill>
+                      <a:prstDash val="solid"/>
+                      <a:round/>
+                      <a:headEnd type="none" w="med" len="med"/>
+                      <a:tailEnd type="none" w="med" len="med"/>
+                    </a:lnT>
+                    <a:lnB w="12700" cap="flat" cmpd="sng" algn="ctr">
+                      <a:solidFill>
+                        <a:srgbClr val="E2E8ED"/>
+                      </a:solidFill>
+                      <a:prstDash val="solid"/>
+                      <a:round/>
+                      <a:headEnd type="none" w="med" len="med"/>
+                      <a:tailEnd type="none" w="med" len="med"/>
+                    </a:lnB>
+                  </a:tcPr>
+                </a:tc>
+                <a:tc>
+                  <a:txBody>
+                    <a:bodyPr/>
+                    <a:lstStyle/>
+                    <a:p>
+                      <a:pPr indent="0" marL="0">
+                        <a:buNone/>
+                      </a:pPr>
+                      <a:r>
+                        <a:rPr lang="en-US" sz="1250" b="1" dirty="0">
+                          <a:solidFill>
+                            <a:srgbClr val="1A1A1A"/>
+                          </a:solidFill>
+                          <a:latin typeface="Meiryo" pitchFamily="34" charset="0"/>
+                          <a:ea typeface="Meiryo" pitchFamily="34" charset="-122"/>
+                          <a:cs typeface="Meiryo" pitchFamily="34" charset="-120"/>
+                        </a:rPr>
+                        <a:t>読み方</a:t>
+                      </a:r>
+                      <a:endParaRPr lang="en-US" sz="1250" dirty="0">
+                        <a:latin typeface="Meiryo" charset="0"/>
+                        <a:ea typeface="Meiryo" charset="0"/>
+                        <a:cs typeface="Meiryo" charset="0"/>
+                      </a:endParaRPr>
+                    </a:p>
+                  </a:txBody>
+                  <a:tcPr marL="91440" marR="91440" marT="45720" marB="45720" anchor="ctr">
+                    <a:lnL w="12700" cap="flat" cmpd="sng" algn="ctr">
+                      <a:solidFill>
+                        <a:srgbClr val="E2E8ED"/>
+                      </a:solidFill>
+                      <a:prstDash val="solid"/>
+                      <a:round/>
+                      <a:headEnd type="none" w="med" len="med"/>
+                      <a:tailEnd type="none" w="med" len="med"/>
+                    </a:lnL>
+                    <a:lnR w="12700" cap="flat" cmpd="sng" algn="ctr">
+                      <a:solidFill>
+                        <a:srgbClr val="E2E8ED"/>
+                      </a:solidFill>
+                      <a:prstDash val="solid"/>
+                      <a:round/>
+                      <a:headEnd type="none" w="med" len="med"/>
+                      <a:tailEnd type="none" w="med" len="med"/>
+                    </a:lnR>
+                    <a:lnT w="12700" cap="flat" cmpd="sng" algn="ctr">
+                      <a:solidFill>
+                        <a:srgbClr val="E2E8ED"/>
+                      </a:solidFill>
+                      <a:prstDash val="solid"/>
+                      <a:round/>
+                      <a:headEnd type="none" w="med" len="med"/>
+                      <a:tailEnd type="none" w="med" len="med"/>
+                    </a:lnT>
+                    <a:lnB w="12700" cap="flat" cmpd="sng" algn="ctr">
+                      <a:solidFill>
+                        <a:srgbClr val="E2E8ED"/>
+                      </a:solidFill>
+                      <a:prstDash val="solid"/>
+                      <a:round/>
+                      <a:headEnd type="none" w="med" len="med"/>
+                      <a:tailEnd type="none" w="med" len="med"/>
+                    </a:lnB>
+                  </a:tcPr>
+                </a:tc>
+              </a:tr>
+              <a:tr h="384048">
+                <a:tc>
+                  <a:txBody>
+                    <a:bodyPr/>
+                    <a:lstStyle/>
+                    <a:p>
+                      <a:pPr indent="0" marL="0">
+                        <a:buNone/>
+                      </a:pPr>
+                      <a:r>
+                        <a:rPr lang="en-US" sz="1250" b="1" dirty="0">
+                          <a:solidFill>
+                            <a:srgbClr val="065A82"/>
+                          </a:solidFill>
+                          <a:latin typeface="Meiryo" pitchFamily="34" charset="0"/>
+                          <a:ea typeface="Meiryo" pitchFamily="34" charset="-122"/>
+                          <a:cs typeface="Meiryo" pitchFamily="34" charset="-120"/>
+                        </a:rPr>
+                        <a:t>オホーツク海 南部の気圧偏差</a:t>
+                      </a:r>
+                      <a:endParaRPr lang="en-US" sz="1250" dirty="0">
+                        <a:latin typeface="Meiryo" charset="0"/>
+                        <a:ea typeface="Meiryo" charset="0"/>
+                        <a:cs typeface="Meiryo" charset="0"/>
+                      </a:endParaRPr>
+                    </a:p>
+                  </a:txBody>
+                  <a:tcPr marL="91440" marR="91440" marT="45720" marB="45720" anchor="ctr">
+                    <a:lnL w="12700" cap="flat" cmpd="sng" algn="ctr">
+                      <a:solidFill>
+                        <a:srgbClr val="E2E8ED"/>
+                      </a:solidFill>
+                      <a:prstDash val="solid"/>
+                      <a:round/>
+                      <a:headEnd type="none" w="med" len="med"/>
+                      <a:tailEnd type="none" w="med" len="med"/>
+                    </a:lnL>
+                    <a:lnR w="12700" cap="flat" cmpd="sng" algn="ctr">
+                      <a:solidFill>
+                        <a:srgbClr val="E2E8ED"/>
+                      </a:solidFill>
+                      <a:prstDash val="solid"/>
+                      <a:round/>
+                      <a:headEnd type="none" w="med" len="med"/>
+                      <a:tailEnd type="none" w="med" len="med"/>
+                    </a:lnR>
+                    <a:lnT w="12700" cap="flat" cmpd="sng" algn="ctr">
+                      <a:solidFill>
+                        <a:srgbClr val="E2E8ED"/>
+                      </a:solidFill>
+                      <a:prstDash val="solid"/>
+                      <a:round/>
+                      <a:headEnd type="none" w="med" len="med"/>
+                      <a:tailEnd type="none" w="med" len="med"/>
+                    </a:lnT>
+                    <a:lnB w="12700" cap="flat" cmpd="sng" algn="ctr">
+                      <a:solidFill>
+                        <a:srgbClr val="E2E8ED"/>
+                      </a:solidFill>
+                      <a:prstDash val="solid"/>
+                      <a:round/>
+                      <a:headEnd type="none" w="med" len="med"/>
+                      <a:tailEnd type="none" w="med" len="med"/>
+                    </a:lnB>
+                  </a:tcPr>
+                </a:tc>
+                <a:tc>
+                  <a:txBody>
+                    <a:bodyPr/>
+                    <a:lstStyle/>
+                    <a:p>
+                      <a:pPr algn="r" indent="0" marL="0">
+                        <a:buNone/>
+                      </a:pPr>
+                      <a:r>
+                        <a:rPr lang="en-US" sz="1250" b="1" dirty="0">
+                          <a:solidFill>
+                            <a:srgbClr val="065A82"/>
+                          </a:solidFill>
+                          <a:latin typeface="Meiryo" pitchFamily="34" charset="0"/>
+                          <a:ea typeface="Meiryo" pitchFamily="34" charset="-122"/>
+                          <a:cs typeface="Meiryo" pitchFamily="34" charset="-120"/>
+                        </a:rPr>
+                        <a:t>0.867</a:t>
+                      </a:r>
+                      <a:endParaRPr lang="en-US" sz="1250" dirty="0">
+                        <a:latin typeface="Meiryo" charset="0"/>
+                        <a:ea typeface="Meiryo" charset="0"/>
+                        <a:cs typeface="Meiryo" charset="0"/>
+                      </a:endParaRPr>
+                    </a:p>
+                  </a:txBody>
+                  <a:tcPr marL="91440" marR="91440" marT="45720" marB="45720" anchor="ctr">
+                    <a:lnL w="12700" cap="flat" cmpd="sng" algn="ctr">
+                      <a:solidFill>
+                        <a:srgbClr val="E2E8ED"/>
+                      </a:solidFill>
+                      <a:prstDash val="solid"/>
+                      <a:round/>
+                      <a:headEnd type="none" w="med" len="med"/>
+                      <a:tailEnd type="none" w="med" len="med"/>
+                    </a:lnL>
+                    <a:lnR w="12700" cap="flat" cmpd="sng" algn="ctr">
+                      <a:solidFill>
+                        <a:srgbClr val="E2E8ED"/>
+                      </a:solidFill>
+                      <a:prstDash val="solid"/>
+                      <a:round/>
+                      <a:headEnd type="none" w="med" len="med"/>
+                      <a:tailEnd type="none" w="med" len="med"/>
+                    </a:lnR>
+                    <a:lnT w="12700" cap="flat" cmpd="sng" algn="ctr">
+                      <a:solidFill>
+                        <a:srgbClr val="E2E8ED"/>
+                      </a:solidFill>
+                      <a:prstDash val="solid"/>
+                      <a:round/>
+                      <a:headEnd type="none" w="med" len="med"/>
+                      <a:tailEnd type="none" w="med" len="med"/>
+                    </a:lnT>
+                    <a:lnB w="12700" cap="flat" cmpd="sng" algn="ctr">
+                      <a:solidFill>
+                        <a:srgbClr val="E2E8ED"/>
+                      </a:solidFill>
+                      <a:prstDash val="solid"/>
+                      <a:round/>
+                      <a:headEnd type="none" w="med" len="med"/>
+                      <a:tailEnd type="none" w="med" len="med"/>
+                    </a:lnB>
+                  </a:tcPr>
+                </a:tc>
+                <a:tc>
+                  <a:txBody>
+                    <a:bodyPr/>
+                    <a:lstStyle/>
+                    <a:p>
+                      <a:pPr algn="r" indent="0" marL="0">
+                        <a:buNone/>
+                      </a:pPr>
+                      <a:r>
+                        <a:rPr lang="en-US" sz="1250" dirty="0">
+                          <a:solidFill>
+                            <a:srgbClr val="1A1A1A"/>
+                          </a:solidFill>
+                          <a:latin typeface="Meiryo" pitchFamily="34" charset="0"/>
+                          <a:ea typeface="Meiryo" pitchFamily="34" charset="-122"/>
+                          <a:cs typeface="Meiryo" pitchFamily="34" charset="-120"/>
+                        </a:rPr>
+                        <a:t>+2.29</a:t>
+                      </a:r>
+                      <a:endParaRPr lang="en-US" sz="1250" dirty="0">
+                        <a:latin typeface="Meiryo" charset="0"/>
+                        <a:ea typeface="Meiryo" charset="0"/>
+                        <a:cs typeface="Meiryo" charset="0"/>
+                      </a:endParaRPr>
+                    </a:p>
+                  </a:txBody>
+                  <a:tcPr marL="91440" marR="91440" marT="45720" marB="45720" anchor="ctr">
+                    <a:lnL w="12700" cap="flat" cmpd="sng" algn="ctr">
+                      <a:solidFill>
+                        <a:srgbClr val="E2E8ED"/>
+                      </a:solidFill>
+                      <a:prstDash val="solid"/>
+                      <a:round/>
+                      <a:headEnd type="none" w="med" len="med"/>
+                      <a:tailEnd type="none" w="med" len="med"/>
+                    </a:lnL>
+                    <a:lnR w="12700" cap="flat" cmpd="sng" algn="ctr">
+                      <a:solidFill>
+                        <a:srgbClr val="E2E8ED"/>
+                      </a:solidFill>
+                      <a:prstDash val="solid"/>
+                      <a:round/>
+                      <a:headEnd type="none" w="med" len="med"/>
+                      <a:tailEnd type="none" w="med" len="med"/>
+                    </a:lnR>
+                    <a:lnT w="12700" cap="flat" cmpd="sng" algn="ctr">
+                      <a:solidFill>
+                        <a:srgbClr val="E2E8ED"/>
+                      </a:solidFill>
+                      <a:prstDash val="solid"/>
+                      <a:round/>
+                      <a:headEnd type="none" w="med" len="med"/>
+                      <a:tailEnd type="none" w="med" len="med"/>
+                    </a:lnT>
+                    <a:lnB w="12700" cap="flat" cmpd="sng" algn="ctr">
+                      <a:solidFill>
+                        <a:srgbClr val="E2E8ED"/>
+                      </a:solidFill>
+                      <a:prstDash val="solid"/>
+                      <a:round/>
+                      <a:headEnd type="none" w="med" len="med"/>
+                      <a:tailEnd type="none" w="med" len="med"/>
+                    </a:lnB>
+                  </a:tcPr>
+                </a:tc>
+                <a:tc>
+                  <a:txBody>
+                    <a:bodyPr/>
+                    <a:lstStyle/>
+                    <a:p>
+                      <a:pPr indent="0" marL="0">
+                        <a:buNone/>
+                      </a:pPr>
+                      <a:r>
+                        <a:rPr lang="en-US" sz="1250" dirty="0">
+                          <a:solidFill>
+                            <a:srgbClr val="1A1A1A"/>
+                          </a:solidFill>
+                          <a:latin typeface="Meiryo" pitchFamily="34" charset="0"/>
+                          <a:ea typeface="Meiryo" pitchFamily="34" charset="-122"/>
+                          <a:cs typeface="Meiryo" pitchFamily="34" charset="-120"/>
+                        </a:rPr>
+                        <a:t>南部が高圧なほど該当しやすい</a:t>
+                      </a:r>
+                      <a:endParaRPr lang="en-US" sz="1250" dirty="0">
+                        <a:latin typeface="Meiryo" charset="0"/>
+                        <a:ea typeface="Meiryo" charset="0"/>
+                        <a:cs typeface="Meiryo" charset="0"/>
+                      </a:endParaRPr>
+                    </a:p>
+                  </a:txBody>
+                  <a:tcPr marL="91440" marR="91440" marT="45720" marB="45720" anchor="ctr">
+                    <a:lnL w="12700" cap="flat" cmpd="sng" algn="ctr">
+                      <a:solidFill>
+                        <a:srgbClr val="E2E8ED"/>
+                      </a:solidFill>
+                      <a:prstDash val="solid"/>
+                      <a:round/>
+                      <a:headEnd type="none" w="med" len="med"/>
+                      <a:tailEnd type="none" w="med" len="med"/>
+                    </a:lnL>
+                    <a:lnR w="12700" cap="flat" cmpd="sng" algn="ctr">
+                      <a:solidFill>
+                        <a:srgbClr val="E2E8ED"/>
+                      </a:solidFill>
+                      <a:prstDash val="solid"/>
+                      <a:round/>
+                      <a:headEnd type="none" w="med" len="med"/>
+                      <a:tailEnd type="none" w="med" len="med"/>
+                    </a:lnR>
+                    <a:lnT w="12700" cap="flat" cmpd="sng" algn="ctr">
+                      <a:solidFill>
+                        <a:srgbClr val="E2E8ED"/>
+                      </a:solidFill>
+                      <a:prstDash val="solid"/>
+                      <a:round/>
+                      <a:headEnd type="none" w="med" len="med"/>
+                      <a:tailEnd type="none" w="med" len="med"/>
+                    </a:lnT>
+                    <a:lnB w="12700" cap="flat" cmpd="sng" algn="ctr">
+                      <a:solidFill>
+                        <a:srgbClr val="E2E8ED"/>
+                      </a:solidFill>
+                      <a:prstDash val="solid"/>
+                      <a:round/>
+                      <a:headEnd type="none" w="med" len="med"/>
+                      <a:tailEnd type="none" w="med" len="med"/>
+                    </a:lnB>
+                  </a:tcPr>
+                </a:tc>
+              </a:tr>
+              <a:tr h="384048">
+                <a:tc>
+                  <a:txBody>
+                    <a:bodyPr/>
+                    <a:lstStyle/>
+                    <a:p>
+                      <a:pPr indent="0" marL="0">
+                        <a:buNone/>
+                      </a:pPr>
+                      <a:r>
+                        <a:rPr lang="en-US" sz="1250" dirty="0">
+                          <a:solidFill>
+                            <a:srgbClr val="1A1A1A"/>
+                          </a:solidFill>
+                          <a:latin typeface="Meiryo" pitchFamily="34" charset="0"/>
+                          <a:ea typeface="Meiryo" pitchFamily="34" charset="-122"/>
+                          <a:cs typeface="Meiryo" pitchFamily="34" charset="-120"/>
+                        </a:rPr>
+                        <a:t>オホーツク海 北部の気圧偏差</a:t>
+                      </a:r>
+                      <a:endParaRPr lang="en-US" sz="1250" dirty="0">
+                        <a:latin typeface="Meiryo" charset="0"/>
+                        <a:ea typeface="Meiryo" charset="0"/>
+                        <a:cs typeface="Meiryo" charset="0"/>
+                      </a:endParaRPr>
+                    </a:p>
+                  </a:txBody>
+                  <a:tcPr marL="91440" marR="91440" marT="45720" marB="45720" anchor="ctr">
+                    <a:lnL w="12700" cap="flat" cmpd="sng" algn="ctr">
+                      <a:solidFill>
+                        <a:srgbClr val="E2E8ED"/>
+                      </a:solidFill>
+                      <a:prstDash val="solid"/>
+                      <a:round/>
+                      <a:headEnd type="none" w="med" len="med"/>
+                      <a:tailEnd type="none" w="med" len="med"/>
+                    </a:lnL>
+                    <a:lnR w="12700" cap="flat" cmpd="sng" algn="ctr">
+                      <a:solidFill>
+                        <a:srgbClr val="E2E8ED"/>
+                      </a:solidFill>
+                      <a:prstDash val="solid"/>
+                      <a:round/>
+                      <a:headEnd type="none" w="med" len="med"/>
+                      <a:tailEnd type="none" w="med" len="med"/>
+                    </a:lnR>
+                    <a:lnT w="12700" cap="flat" cmpd="sng" algn="ctr">
+                      <a:solidFill>
+                        <a:srgbClr val="E2E8ED"/>
+                      </a:solidFill>
+                      <a:prstDash val="solid"/>
+                      <a:round/>
+                      <a:headEnd type="none" w="med" len="med"/>
+                      <a:tailEnd type="none" w="med" len="med"/>
+                    </a:lnT>
+                    <a:lnB w="12700" cap="flat" cmpd="sng" algn="ctr">
+                      <a:solidFill>
+                        <a:srgbClr val="E2E8ED"/>
+                      </a:solidFill>
+                      <a:prstDash val="solid"/>
+                      <a:round/>
+                      <a:headEnd type="none" w="med" len="med"/>
+                      <a:tailEnd type="none" w="med" len="med"/>
+                    </a:lnB>
+                  </a:tcPr>
+                </a:tc>
+                <a:tc>
+                  <a:txBody>
+                    <a:bodyPr/>
+                    <a:lstStyle/>
+                    <a:p>
+                      <a:pPr algn="r" indent="0" marL="0">
+                        <a:buNone/>
+                      </a:pPr>
+                      <a:r>
+                        <a:rPr lang="en-US" sz="1250" dirty="0">
+                          <a:solidFill>
+                            <a:srgbClr val="1A1A1A"/>
+                          </a:solidFill>
+                          <a:latin typeface="Meiryo" pitchFamily="34" charset="0"/>
+                          <a:ea typeface="Meiryo" pitchFamily="34" charset="-122"/>
+                          <a:cs typeface="Meiryo" pitchFamily="34" charset="-120"/>
+                        </a:rPr>
+                        <a:t>0.783</a:t>
+                      </a:r>
+                      <a:endParaRPr lang="en-US" sz="1250" dirty="0">
+                        <a:latin typeface="Meiryo" charset="0"/>
+                        <a:ea typeface="Meiryo" charset="0"/>
+                        <a:cs typeface="Meiryo" charset="0"/>
+                      </a:endParaRPr>
+                    </a:p>
+                  </a:txBody>
+                  <a:tcPr marL="91440" marR="91440" marT="45720" marB="45720" anchor="ctr">
+                    <a:lnL w="12700" cap="flat" cmpd="sng" algn="ctr">
+                      <a:solidFill>
+                        <a:srgbClr val="E2E8ED"/>
+                      </a:solidFill>
+                      <a:prstDash val="solid"/>
+                      <a:round/>
+                      <a:headEnd type="none" w="med" len="med"/>
+                      <a:tailEnd type="none" w="med" len="med"/>
+                    </a:lnL>
+                    <a:lnR w="12700" cap="flat" cmpd="sng" algn="ctr">
+                      <a:solidFill>
+                        <a:srgbClr val="E2E8ED"/>
+                      </a:solidFill>
+                      <a:prstDash val="solid"/>
+                      <a:round/>
+                      <a:headEnd type="none" w="med" len="med"/>
+                      <a:tailEnd type="none" w="med" len="med"/>
+                    </a:lnR>
+                    <a:lnT w="12700" cap="flat" cmpd="sng" algn="ctr">
+                      <a:solidFill>
+                        <a:srgbClr val="E2E8ED"/>
+                      </a:solidFill>
+                      <a:prstDash val="solid"/>
+                      <a:round/>
+                      <a:headEnd type="none" w="med" len="med"/>
+                      <a:tailEnd type="none" w="med" len="med"/>
+                    </a:lnT>
+                    <a:lnB w="12700" cap="flat" cmpd="sng" algn="ctr">
+                      <a:solidFill>
+                        <a:srgbClr val="E2E8ED"/>
+                      </a:solidFill>
+                      <a:prstDash val="solid"/>
+                      <a:round/>
+                      <a:headEnd type="none" w="med" len="med"/>
+                      <a:tailEnd type="none" w="med" len="med"/>
+                    </a:lnB>
+                  </a:tcPr>
+                </a:tc>
+                <a:tc>
+                  <a:txBody>
+                    <a:bodyPr/>
+                    <a:lstStyle/>
+                    <a:p>
+                      <a:pPr algn="r" indent="0" marL="0">
+                        <a:buNone/>
+                      </a:pPr>
+                      <a:r>
+                        <a:rPr lang="en-US" sz="1250" dirty="0">
+                          <a:solidFill>
+                            <a:srgbClr val="1A1A1A"/>
+                          </a:solidFill>
+                          <a:latin typeface="Meiryo" pitchFamily="34" charset="0"/>
+                          <a:ea typeface="Meiryo" pitchFamily="34" charset="-122"/>
+                          <a:cs typeface="Meiryo" pitchFamily="34" charset="-120"/>
+                        </a:rPr>
+                        <a:t>+1.23</a:t>
+                      </a:r>
+                      <a:endParaRPr lang="en-US" sz="1250" dirty="0">
+                        <a:latin typeface="Meiryo" charset="0"/>
+                        <a:ea typeface="Meiryo" charset="0"/>
+                        <a:cs typeface="Meiryo" charset="0"/>
+                      </a:endParaRPr>
+                    </a:p>
+                  </a:txBody>
+                  <a:tcPr marL="91440" marR="91440" marT="45720" marB="45720" anchor="ctr">
+                    <a:lnL w="12700" cap="flat" cmpd="sng" algn="ctr">
+                      <a:solidFill>
+                        <a:srgbClr val="E2E8ED"/>
+                      </a:solidFill>
+                      <a:prstDash val="solid"/>
+                      <a:round/>
+                      <a:headEnd type="none" w="med" len="med"/>
+                      <a:tailEnd type="none" w="med" len="med"/>
+                    </a:lnL>
+                    <a:lnR w="12700" cap="flat" cmpd="sng" algn="ctr">
+                      <a:solidFill>
+                        <a:srgbClr val="E2E8ED"/>
+                      </a:solidFill>
+                      <a:prstDash val="solid"/>
+                      <a:round/>
+                      <a:headEnd type="none" w="med" len="med"/>
+                      <a:tailEnd type="none" w="med" len="med"/>
+                    </a:lnR>
+                    <a:lnT w="12700" cap="flat" cmpd="sng" algn="ctr">
+                      <a:solidFill>
+                        <a:srgbClr val="E2E8ED"/>
+                      </a:solidFill>
+                      <a:prstDash val="solid"/>
+                      <a:round/>
+                      <a:headEnd type="none" w="med" len="med"/>
+                      <a:tailEnd type="none" w="med" len="med"/>
+                    </a:lnT>
+                    <a:lnB w="12700" cap="flat" cmpd="sng" algn="ctr">
+                      <a:solidFill>
+                        <a:srgbClr val="E2E8ED"/>
+                      </a:solidFill>
+                      <a:prstDash val="solid"/>
+                      <a:round/>
+                      <a:headEnd type="none" w="med" len="med"/>
+                      <a:tailEnd type="none" w="med" len="med"/>
+                    </a:lnB>
+                  </a:tcPr>
+                </a:tc>
+                <a:tc>
+                  <a:txBody>
+                    <a:bodyPr/>
+                    <a:lstStyle/>
+                    <a:p>
+                      <a:pPr indent="0" marL="0">
+                        <a:buNone/>
+                      </a:pPr>
+                      <a:r>
+                        <a:rPr lang="en-US" sz="1250" dirty="0">
+                          <a:solidFill>
+                            <a:srgbClr val="1A1A1A"/>
+                          </a:solidFill>
+                          <a:latin typeface="Meiryo" pitchFamily="34" charset="0"/>
+                          <a:ea typeface="Meiryo" pitchFamily="34" charset="-122"/>
+                          <a:cs typeface="Meiryo" pitchFamily="34" charset="-120"/>
+                        </a:rPr>
+                        <a:t>北部の寄与は南部より小さい</a:t>
+                      </a:r>
+                      <a:endParaRPr lang="en-US" sz="1250" dirty="0">
+                        <a:latin typeface="Meiryo" charset="0"/>
+                        <a:ea typeface="Meiryo" charset="0"/>
+                        <a:cs typeface="Meiryo" charset="0"/>
+                      </a:endParaRPr>
+                    </a:p>
+                  </a:txBody>
+                  <a:tcPr marL="91440" marR="91440" marT="45720" marB="45720" anchor="ctr">
+                    <a:lnL w="12700" cap="flat" cmpd="sng" algn="ctr">
+                      <a:solidFill>
+                        <a:srgbClr val="E2E8ED"/>
+                      </a:solidFill>
+                      <a:prstDash val="solid"/>
+                      <a:round/>
+                      <a:headEnd type="none" w="med" len="med"/>
+                      <a:tailEnd type="none" w="med" len="med"/>
+                    </a:lnL>
+                    <a:lnR w="12700" cap="flat" cmpd="sng" algn="ctr">
+                      <a:solidFill>
+                        <a:srgbClr val="E2E8ED"/>
+                      </a:solidFill>
+                      <a:prstDash val="solid"/>
+                      <a:round/>
+                      <a:headEnd type="none" w="med" len="med"/>
+                      <a:tailEnd type="none" w="med" len="med"/>
+                    </a:lnR>
+                    <a:lnT w="12700" cap="flat" cmpd="sng" algn="ctr">
+                      <a:solidFill>
+                        <a:srgbClr val="E2E8ED"/>
+                      </a:solidFill>
+                      <a:prstDash val="solid"/>
+                      <a:round/>
+                      <a:headEnd type="none" w="med" len="med"/>
+                      <a:tailEnd type="none" w="med" len="med"/>
+                    </a:lnT>
+                    <a:lnB w="12700" cap="flat" cmpd="sng" algn="ctr">
+                      <a:solidFill>
+                        <a:srgbClr val="E2E8ED"/>
+                      </a:solidFill>
+                      <a:prstDash val="solid"/>
+                      <a:round/>
+                      <a:headEnd type="none" w="med" len="med"/>
+                      <a:tailEnd type="none" w="med" len="med"/>
+                    </a:lnB>
+                  </a:tcPr>
+                </a:tc>
+              </a:tr>
+              <a:tr h="384048">
+                <a:tc>
+                  <a:txBody>
+                    <a:bodyPr/>
+                    <a:lstStyle/>
+                    <a:p>
+                      <a:pPr indent="0" marL="0">
+                        <a:buNone/>
+                      </a:pPr>
+                      <a:r>
+                        <a:rPr lang="en-US" sz="1250" b="1" dirty="0">
+                          <a:solidFill>
+                            <a:srgbClr val="065A82"/>
+                          </a:solidFill>
+                          <a:latin typeface="Meiryo" pitchFamily="34" charset="0"/>
+                          <a:ea typeface="Meiryo" pitchFamily="34" charset="-122"/>
+                          <a:cs typeface="Meiryo" pitchFamily="34" charset="-120"/>
+                        </a:rPr>
+                        <a:t>北日本の東西風（地衡風）</a:t>
+                      </a:r>
+                      <a:endParaRPr lang="en-US" sz="1250" dirty="0">
+                        <a:latin typeface="Meiryo" charset="0"/>
+                        <a:ea typeface="Meiryo" charset="0"/>
+                        <a:cs typeface="Meiryo" charset="0"/>
+                      </a:endParaRPr>
+                    </a:p>
+                  </a:txBody>
+                  <a:tcPr marL="91440" marR="91440" marT="45720" marB="45720" anchor="ctr">
+                    <a:lnL w="12700" cap="flat" cmpd="sng" algn="ctr">
+                      <a:solidFill>
+                        <a:srgbClr val="E2E8ED"/>
+                      </a:solidFill>
+                      <a:prstDash val="solid"/>
+                      <a:round/>
+                      <a:headEnd type="none" w="med" len="med"/>
+                      <a:tailEnd type="none" w="med" len="med"/>
+                    </a:lnL>
+                    <a:lnR w="12700" cap="flat" cmpd="sng" algn="ctr">
+                      <a:solidFill>
+                        <a:srgbClr val="E2E8ED"/>
+                      </a:solidFill>
+                      <a:prstDash val="solid"/>
+                      <a:round/>
+                      <a:headEnd type="none" w="med" len="med"/>
+                      <a:tailEnd type="none" w="med" len="med"/>
+                    </a:lnR>
+                    <a:lnT w="12700" cap="flat" cmpd="sng" algn="ctr">
+                      <a:solidFill>
+                        <a:srgbClr val="E2E8ED"/>
+                      </a:solidFill>
+                      <a:prstDash val="solid"/>
+                      <a:round/>
+                      <a:headEnd type="none" w="med" len="med"/>
+                      <a:tailEnd type="none" w="med" len="med"/>
+                    </a:lnT>
+                    <a:lnB w="12700" cap="flat" cmpd="sng" algn="ctr">
+                      <a:solidFill>
+                        <a:srgbClr val="E2E8ED"/>
+                      </a:solidFill>
+                      <a:prstDash val="solid"/>
+                      <a:round/>
+                      <a:headEnd type="none" w="med" len="med"/>
+                      <a:tailEnd type="none" w="med" len="med"/>
+                    </a:lnB>
+                  </a:tcPr>
+                </a:tc>
+                <a:tc>
+                  <a:txBody>
+                    <a:bodyPr/>
+                    <a:lstStyle/>
+                    <a:p>
+                      <a:pPr algn="r" indent="0" marL="0">
+                        <a:buNone/>
+                      </a:pPr>
+                      <a:r>
+                        <a:rPr lang="en-US" sz="1250" b="1" dirty="0">
+                          <a:solidFill>
+                            <a:srgbClr val="065A82"/>
+                          </a:solidFill>
+                          <a:latin typeface="Meiryo" pitchFamily="34" charset="0"/>
+                          <a:ea typeface="Meiryo" pitchFamily="34" charset="-122"/>
+                          <a:cs typeface="Meiryo" pitchFamily="34" charset="-120"/>
+                        </a:rPr>
+                        <a:t>0.807</a:t>
+                      </a:r>
+                      <a:endParaRPr lang="en-US" sz="1250" dirty="0">
+                        <a:latin typeface="Meiryo" charset="0"/>
+                        <a:ea typeface="Meiryo" charset="0"/>
+                        <a:cs typeface="Meiryo" charset="0"/>
+                      </a:endParaRPr>
+                    </a:p>
+                  </a:txBody>
+                  <a:tcPr marL="91440" marR="91440" marT="45720" marB="45720" anchor="ctr">
+                    <a:lnL w="12700" cap="flat" cmpd="sng" algn="ctr">
+                      <a:solidFill>
+                        <a:srgbClr val="E2E8ED"/>
+                      </a:solidFill>
+                      <a:prstDash val="solid"/>
+                      <a:round/>
+                      <a:headEnd type="none" w="med" len="med"/>
+                      <a:tailEnd type="none" w="med" len="med"/>
+                    </a:lnL>
+                    <a:lnR w="12700" cap="flat" cmpd="sng" algn="ctr">
+                      <a:solidFill>
+                        <a:srgbClr val="E2E8ED"/>
+                      </a:solidFill>
+                      <a:prstDash val="solid"/>
+                      <a:round/>
+                      <a:headEnd type="none" w="med" len="med"/>
+                      <a:tailEnd type="none" w="med" len="med"/>
+                    </a:lnR>
+                    <a:lnT w="12700" cap="flat" cmpd="sng" algn="ctr">
+                      <a:solidFill>
+                        <a:srgbClr val="E2E8ED"/>
+                      </a:solidFill>
+                      <a:prstDash val="solid"/>
+                      <a:round/>
+                      <a:headEnd type="none" w="med" len="med"/>
+                      <a:tailEnd type="none" w="med" len="med"/>
+                    </a:lnT>
+                    <a:lnB w="12700" cap="flat" cmpd="sng" algn="ctr">
+                      <a:solidFill>
+                        <a:srgbClr val="E2E8ED"/>
+                      </a:solidFill>
+                      <a:prstDash val="solid"/>
+                      <a:round/>
+                      <a:headEnd type="none" w="med" len="med"/>
+                      <a:tailEnd type="none" w="med" len="med"/>
+                    </a:lnB>
+                  </a:tcPr>
+                </a:tc>
+                <a:tc>
+                  <a:txBody>
+                    <a:bodyPr/>
+                    <a:lstStyle/>
+                    <a:p>
+                      <a:pPr algn="r" indent="0" marL="0">
+                        <a:buNone/>
+                      </a:pPr>
+                      <a:r>
+                        <a:rPr lang="en-US" sz="1250" dirty="0">
+                          <a:solidFill>
+                            <a:srgbClr val="1A1A1A"/>
+                          </a:solidFill>
+                          <a:latin typeface="Meiryo" pitchFamily="34" charset="0"/>
+                          <a:ea typeface="Meiryo" pitchFamily="34" charset="-122"/>
+                          <a:cs typeface="Meiryo" pitchFamily="34" charset="-120"/>
+                        </a:rPr>
+                        <a:t>−1.76</a:t>
+                      </a:r>
+                      <a:endParaRPr lang="en-US" sz="1250" dirty="0">
+                        <a:latin typeface="Meiryo" charset="0"/>
+                        <a:ea typeface="Meiryo" charset="0"/>
+                        <a:cs typeface="Meiryo" charset="0"/>
+                      </a:endParaRPr>
+                    </a:p>
+                  </a:txBody>
+                  <a:tcPr marL="91440" marR="91440" marT="45720" marB="45720" anchor="ctr">
+                    <a:lnL w="12700" cap="flat" cmpd="sng" algn="ctr">
+                      <a:solidFill>
+                        <a:srgbClr val="E2E8ED"/>
+                      </a:solidFill>
+                      <a:prstDash val="solid"/>
+                      <a:round/>
+                      <a:headEnd type="none" w="med" len="med"/>
+                      <a:tailEnd type="none" w="med" len="med"/>
+                    </a:lnL>
+                    <a:lnR w="12700" cap="flat" cmpd="sng" algn="ctr">
+                      <a:solidFill>
+                        <a:srgbClr val="E2E8ED"/>
+                      </a:solidFill>
+                      <a:prstDash val="solid"/>
+                      <a:round/>
+                      <a:headEnd type="none" w="med" len="med"/>
+                      <a:tailEnd type="none" w="med" len="med"/>
+                    </a:lnR>
+                    <a:lnT w="12700" cap="flat" cmpd="sng" algn="ctr">
+                      <a:solidFill>
+                        <a:srgbClr val="E2E8ED"/>
+                      </a:solidFill>
+                      <a:prstDash val="solid"/>
+                      <a:round/>
+                      <a:headEnd type="none" w="med" len="med"/>
+                      <a:tailEnd type="none" w="med" len="med"/>
+                    </a:lnT>
+                    <a:lnB w="12700" cap="flat" cmpd="sng" algn="ctr">
+                      <a:solidFill>
+                        <a:srgbClr val="E2E8ED"/>
+                      </a:solidFill>
+                      <a:prstDash val="solid"/>
+                      <a:round/>
+                      <a:headEnd type="none" w="med" len="med"/>
+                      <a:tailEnd type="none" w="med" len="med"/>
+                    </a:lnB>
+                  </a:tcPr>
+                </a:tc>
+                <a:tc>
+                  <a:txBody>
+                    <a:bodyPr/>
+                    <a:lstStyle/>
+                    <a:p>
+                      <a:pPr indent="0" marL="0">
+                        <a:buNone/>
+                      </a:pPr>
+                      <a:r>
+                        <a:rPr lang="en-US" sz="1250" dirty="0">
+                          <a:solidFill>
+                            <a:srgbClr val="1A1A1A"/>
+                          </a:solidFill>
+                          <a:latin typeface="Meiryo" pitchFamily="34" charset="0"/>
+                          <a:ea typeface="Meiryo" pitchFamily="34" charset="-122"/>
+                          <a:cs typeface="Meiryo" pitchFamily="34" charset="-120"/>
+                        </a:rPr>
+                        <a:t>負＝東寄りの風。やませに対応</a:t>
+                      </a:r>
+                      <a:endParaRPr lang="en-US" sz="1250" dirty="0">
+                        <a:latin typeface="Meiryo" charset="0"/>
+                        <a:ea typeface="Meiryo" charset="0"/>
+                        <a:cs typeface="Meiryo" charset="0"/>
+                      </a:endParaRPr>
+                    </a:p>
+                  </a:txBody>
+                  <a:tcPr marL="91440" marR="91440" marT="45720" marB="45720" anchor="ctr">
+                    <a:lnL w="12700" cap="flat" cmpd="sng" algn="ctr">
+                      <a:solidFill>
+                        <a:srgbClr val="E2E8ED"/>
+                      </a:solidFill>
+                      <a:prstDash val="solid"/>
+                      <a:round/>
+                      <a:headEnd type="none" w="med" len="med"/>
+                      <a:tailEnd type="none" w="med" len="med"/>
+                    </a:lnL>
+                    <a:lnR w="12700" cap="flat" cmpd="sng" algn="ctr">
+                      <a:solidFill>
+                        <a:srgbClr val="E2E8ED"/>
+                      </a:solidFill>
+                      <a:prstDash val="solid"/>
+                      <a:round/>
+                      <a:headEnd type="none" w="med" len="med"/>
+                      <a:tailEnd type="none" w="med" len="med"/>
+                    </a:lnR>
+                    <a:lnT w="12700" cap="flat" cmpd="sng" algn="ctr">
+                      <a:solidFill>
+                        <a:srgbClr val="E2E8ED"/>
+                      </a:solidFill>
+                      <a:prstDash val="solid"/>
+                      <a:round/>
+                      <a:headEnd type="none" w="med" len="med"/>
+                      <a:tailEnd type="none" w="med" len="med"/>
+                    </a:lnT>
+                    <a:lnB w="12700" cap="flat" cmpd="sng" algn="ctr">
+                      <a:solidFill>
+                        <a:srgbClr val="E2E8ED"/>
+                      </a:solidFill>
+                      <a:prstDash val="solid"/>
+                      <a:round/>
+                      <a:headEnd type="none" w="med" len="med"/>
+                      <a:tailEnd type="none" w="med" len="med"/>
+                    </a:lnB>
+                  </a:tcPr>
+                </a:tc>
+              </a:tr>
+              <a:tr h="384048">
+                <a:tc>
+                  <a:txBody>
+                    <a:bodyPr/>
+                    <a:lstStyle/>
+                    <a:p>
+                      <a:pPr indent="0" marL="0">
+                        <a:buNone/>
+                      </a:pPr>
+                      <a:r>
+                        <a:rPr lang="en-US" sz="1250" dirty="0">
+                          <a:solidFill>
+                            <a:srgbClr val="1A1A1A"/>
+                          </a:solidFill>
+                          <a:latin typeface="Meiryo" pitchFamily="34" charset="0"/>
+                          <a:ea typeface="Meiryo" pitchFamily="34" charset="-122"/>
+                          <a:cs typeface="Meiryo" pitchFamily="34" charset="-120"/>
+                        </a:rPr>
+                        <a:t>高気圧中心の緯度</a:t>
+                      </a:r>
+                      <a:endParaRPr lang="en-US" sz="1250" dirty="0">
+                        <a:latin typeface="Meiryo" charset="0"/>
+                        <a:ea typeface="Meiryo" charset="0"/>
+                        <a:cs typeface="Meiryo" charset="0"/>
+                      </a:endParaRPr>
+                    </a:p>
+                  </a:txBody>
+                  <a:tcPr marL="91440" marR="91440" marT="45720" marB="45720" anchor="ctr">
+                    <a:lnL w="12700" cap="flat" cmpd="sng" algn="ctr">
+                      <a:solidFill>
+                        <a:srgbClr val="E2E8ED"/>
+                      </a:solidFill>
+                      <a:prstDash val="solid"/>
+                      <a:round/>
+                      <a:headEnd type="none" w="med" len="med"/>
+                      <a:tailEnd type="none" w="med" len="med"/>
+                    </a:lnL>
+                    <a:lnR w="12700" cap="flat" cmpd="sng" algn="ctr">
+                      <a:solidFill>
+                        <a:srgbClr val="E2E8ED"/>
+                      </a:solidFill>
+                      <a:prstDash val="solid"/>
+                      <a:round/>
+                      <a:headEnd type="none" w="med" len="med"/>
+                      <a:tailEnd type="none" w="med" len="med"/>
+                    </a:lnR>
+                    <a:lnT w="12700" cap="flat" cmpd="sng" algn="ctr">
+                      <a:solidFill>
+                        <a:srgbClr val="E2E8ED"/>
+                      </a:solidFill>
+                      <a:prstDash val="solid"/>
+                      <a:round/>
+                      <a:headEnd type="none" w="med" len="med"/>
+                      <a:tailEnd type="none" w="med" len="med"/>
+                    </a:lnT>
+                    <a:lnB w="12700" cap="flat" cmpd="sng" algn="ctr">
+                      <a:solidFill>
+                        <a:srgbClr val="E2E8ED"/>
+                      </a:solidFill>
+                      <a:prstDash val="solid"/>
+                      <a:round/>
+                      <a:headEnd type="none" w="med" len="med"/>
+                      <a:tailEnd type="none" w="med" len="med"/>
+                    </a:lnB>
+                  </a:tcPr>
+                </a:tc>
+                <a:tc>
+                  <a:txBody>
+                    <a:bodyPr/>
+                    <a:lstStyle/>
+                    <a:p>
+                      <a:pPr algn="r" indent="0" marL="0">
+                        <a:buNone/>
+                      </a:pPr>
+                      <a:r>
+                        <a:rPr lang="en-US" sz="1250" dirty="0">
+                          <a:solidFill>
+                            <a:srgbClr val="5A6472"/>
+                          </a:solidFill>
+                          <a:latin typeface="Meiryo" pitchFamily="34" charset="0"/>
+                          <a:ea typeface="Meiryo" pitchFamily="34" charset="-122"/>
+                          <a:cs typeface="Meiryo" pitchFamily="34" charset="-120"/>
+                        </a:rPr>
+                        <a:t>0.508</a:t>
+                      </a:r>
+                      <a:endParaRPr lang="en-US" sz="1250" dirty="0">
+                        <a:latin typeface="Meiryo" charset="0"/>
+                        <a:ea typeface="Meiryo" charset="0"/>
+                        <a:cs typeface="Meiryo" charset="0"/>
+                      </a:endParaRPr>
+                    </a:p>
+                  </a:txBody>
+                  <a:tcPr marL="91440" marR="91440" marT="45720" marB="45720" anchor="ctr">
+                    <a:lnL w="12700" cap="flat" cmpd="sng" algn="ctr">
+                      <a:solidFill>
+                        <a:srgbClr val="E2E8ED"/>
+                      </a:solidFill>
+                      <a:prstDash val="solid"/>
+                      <a:round/>
+                      <a:headEnd type="none" w="med" len="med"/>
+                      <a:tailEnd type="none" w="med" len="med"/>
+                    </a:lnL>
+                    <a:lnR w="12700" cap="flat" cmpd="sng" algn="ctr">
+                      <a:solidFill>
+                        <a:srgbClr val="E2E8ED"/>
+                      </a:solidFill>
+                      <a:prstDash val="solid"/>
+                      <a:round/>
+                      <a:headEnd type="none" w="med" len="med"/>
+                      <a:tailEnd type="none" w="med" len="med"/>
+                    </a:lnR>
+                    <a:lnT w="12700" cap="flat" cmpd="sng" algn="ctr">
+                      <a:solidFill>
+                        <a:srgbClr val="E2E8ED"/>
+                      </a:solidFill>
+                      <a:prstDash val="solid"/>
+                      <a:round/>
+                      <a:headEnd type="none" w="med" len="med"/>
+                      <a:tailEnd type="none" w="med" len="med"/>
+                    </a:lnT>
+                    <a:lnB w="12700" cap="flat" cmpd="sng" algn="ctr">
+                      <a:solidFill>
+                        <a:srgbClr val="E2E8ED"/>
+                      </a:solidFill>
+                      <a:prstDash val="solid"/>
+                      <a:round/>
+                      <a:headEnd type="none" w="med" len="med"/>
+                      <a:tailEnd type="none" w="med" len="med"/>
+                    </a:lnB>
+                  </a:tcPr>
+                </a:tc>
+                <a:tc>
+                  <a:txBody>
+                    <a:bodyPr/>
+                    <a:lstStyle/>
+                    <a:p>
+                      <a:pPr algn="r" indent="0" marL="0">
+                        <a:buNone/>
+                      </a:pPr>
+                      <a:r>
+                        <a:rPr lang="en-US" sz="1250" dirty="0">
+                          <a:solidFill>
+                            <a:srgbClr val="5A6472"/>
+                          </a:solidFill>
+                          <a:latin typeface="Meiryo" pitchFamily="34" charset="0"/>
+                          <a:ea typeface="Meiryo" pitchFamily="34" charset="-122"/>
+                          <a:cs typeface="Meiryo" pitchFamily="34" charset="-120"/>
+                        </a:rPr>
+                        <a:t>+0.56</a:t>
+                      </a:r>
+                      <a:endParaRPr lang="en-US" sz="1250" dirty="0">
+                        <a:latin typeface="Meiryo" charset="0"/>
+                        <a:ea typeface="Meiryo" charset="0"/>
+                        <a:cs typeface="Meiryo" charset="0"/>
+                      </a:endParaRPr>
+                    </a:p>
+                  </a:txBody>
+                  <a:tcPr marL="91440" marR="91440" marT="45720" marB="45720" anchor="ctr">
+                    <a:lnL w="12700" cap="flat" cmpd="sng" algn="ctr">
+                      <a:solidFill>
+                        <a:srgbClr val="E2E8ED"/>
+                      </a:solidFill>
+                      <a:prstDash val="solid"/>
+                      <a:round/>
+                      <a:headEnd type="none" w="med" len="med"/>
+                      <a:tailEnd type="none" w="med" len="med"/>
+                    </a:lnL>
+                    <a:lnR w="12700" cap="flat" cmpd="sng" algn="ctr">
+                      <a:solidFill>
+                        <a:srgbClr val="E2E8ED"/>
+                      </a:solidFill>
+                      <a:prstDash val="solid"/>
+                      <a:round/>
+                      <a:headEnd type="none" w="med" len="med"/>
+                      <a:tailEnd type="none" w="med" len="med"/>
+                    </a:lnR>
+                    <a:lnT w="12700" cap="flat" cmpd="sng" algn="ctr">
+                      <a:solidFill>
+                        <a:srgbClr val="E2E8ED"/>
+                      </a:solidFill>
+                      <a:prstDash val="solid"/>
+                      <a:round/>
+                      <a:headEnd type="none" w="med" len="med"/>
+                      <a:tailEnd type="none" w="med" len="med"/>
+                    </a:lnT>
+                    <a:lnB w="12700" cap="flat" cmpd="sng" algn="ctr">
+                      <a:solidFill>
+                        <a:srgbClr val="E2E8ED"/>
+                      </a:solidFill>
+                      <a:prstDash val="solid"/>
+                      <a:round/>
+                      <a:headEnd type="none" w="med" len="med"/>
+                      <a:tailEnd type="none" w="med" len="med"/>
+                    </a:lnB>
+                  </a:tcPr>
+                </a:tc>
+                <a:tc>
+                  <a:txBody>
+                    <a:bodyPr/>
+                    <a:lstStyle/>
+                    <a:p>
+                      <a:pPr indent="0" marL="0">
+                        <a:buNone/>
+                      </a:pPr>
+                      <a:r>
+                        <a:rPr lang="en-US" sz="1250" dirty="0">
+                          <a:solidFill>
+                            <a:srgbClr val="5A6472"/>
+                          </a:solidFill>
+                          <a:latin typeface="Meiryo" pitchFamily="34" charset="0"/>
+                          <a:ea typeface="Meiryo" pitchFamily="34" charset="-122"/>
+                          <a:cs typeface="Meiryo" pitchFamily="34" charset="-120"/>
+                        </a:rPr>
+                        <a:t>効かず。中心位置より領域の高さ</a:t>
+                      </a:r>
+                      <a:endParaRPr lang="en-US" sz="1250" dirty="0">
+                        <a:latin typeface="Meiryo" charset="0"/>
+                        <a:ea typeface="Meiryo" charset="0"/>
+                        <a:cs typeface="Meiryo" charset="0"/>
+                      </a:endParaRPr>
+                    </a:p>
+                  </a:txBody>
+                  <a:tcPr marL="91440" marR="91440" marT="45720" marB="45720" anchor="ctr">
+                    <a:lnL w="12700" cap="flat" cmpd="sng" algn="ctr">
+                      <a:solidFill>
+                        <a:srgbClr val="E2E8ED"/>
+                      </a:solidFill>
+                      <a:prstDash val="solid"/>
+                      <a:round/>
+                      <a:headEnd type="none" w="med" len="med"/>
+                      <a:tailEnd type="none" w="med" len="med"/>
+                    </a:lnL>
+                    <a:lnR w="12700" cap="flat" cmpd="sng" algn="ctr">
+                      <a:solidFill>
+                        <a:srgbClr val="E2E8ED"/>
+                      </a:solidFill>
+                      <a:prstDash val="solid"/>
+                      <a:round/>
+                      <a:headEnd type="none" w="med" len="med"/>
+                      <a:tailEnd type="none" w="med" len="med"/>
+                    </a:lnR>
+                    <a:lnT w="12700" cap="flat" cmpd="sng" algn="ctr">
+                      <a:solidFill>
+                        <a:srgbClr val="E2E8ED"/>
+                      </a:solidFill>
+                      <a:prstDash val="solid"/>
+                      <a:round/>
+                      <a:headEnd type="none" w="med" len="med"/>
+                      <a:tailEnd type="none" w="med" len="med"/>
+                    </a:lnT>
+                    <a:lnB w="12700" cap="flat" cmpd="sng" algn="ctr">
+                      <a:solidFill>
+                        <a:srgbClr val="E2E8ED"/>
+                      </a:solidFill>
+                      <a:prstDash val="solid"/>
+                      <a:round/>
+                      <a:headEnd type="none" w="med" len="med"/>
+                      <a:tailEnd type="none" w="med" len="med"/>
+                    </a:lnB>
+                  </a:tcPr>
+                </a:tc>
+              </a:tr>
+            </a:tbl>
+          </a:graphicData>
+        </a:graphic>
+      </p:graphicFrame>
+      <p:sp>
+        <p:nvSpPr>
+          <p:cNvPr id="8" name="Shape 5"/>
+          <p:cNvSpPr/>
+          <p:nvPr/>
+        </p:nvSpPr>
+        <p:spPr>
+          <a:xfrm>
+            <a:off x="548640" y="5257800"/>
+            <a:ext cx="6949440" cy="1051560"/>
+          </a:xfrm>
+          <a:prstGeom prst="roundRect">
+            <a:avLst>
+              <a:gd name="adj" fmla="val 6957"/>
+            </a:avLst>
           </a:prstGeom>
           <a:solidFill>
-            <a:srgbClr val="B3341F"/>
+            <a:srgbClr val="21295C"/>
           </a:solidFill>
           <a:ln/>
         </p:spPr>
       </p:sp>
       <p:sp>
         <p:nvSpPr>
-          <p:cNvPr id="9" name="Text 7"/>
-          <p:cNvSpPr/>
-          <p:nvPr/>
-        </p:nvSpPr>
-        <p:spPr>
-          <a:xfrm>
-            <a:off x="640080" y="2478024"/>
-            <a:ext cx="402336" cy="310896"/>
+          <p:cNvPr id="9" name="Text 6"/>
+          <p:cNvSpPr/>
+          <p:nvPr/>
+        </p:nvSpPr>
+        <p:spPr>
+          <a:xfrm>
+            <a:off x="822960" y="5422392"/>
+            <a:ext cx="6400800" cy="777240"/>
           </a:xfrm>
           <a:prstGeom prst="rect">
             <a:avLst/>
@@ -8053,7 +10501,7 @@
           <a:bodyPr wrap="square" lIns="0" tIns="0" rIns="0" bIns="0" rtlCol="0" anchor="ctr"/>
           <a:lstStyle/>
           <a:p>
-            <a:pPr algn="ctr" indent="0" marL="0">
+            <a:pPr indent="0" marL="0">
               <a:buNone/>
             </a:pPr>
             <a:r>
@@ -8061,42 +10509,100 @@
                 <a:solidFill>
                   <a:srgbClr val="FFFFFF"/>
                 </a:solidFill>
-                <a:latin typeface="Cambria" pitchFamily="34" charset="0"/>
-                <a:ea typeface="Cambria" pitchFamily="34" charset="-122"/>
-                <a:cs typeface="Cambria" pitchFamily="34" charset="-120"/>
+                <a:latin typeface="Meiryo" pitchFamily="34" charset="0"/>
+                <a:ea typeface="Meiryo" pitchFamily="34" charset="-122"/>
+                <a:cs typeface="Meiryo" pitchFamily="34" charset="-120"/>
               </a:rPr>
-              <a:t>2</a:t>
+              <a:t>符号まで予報官の判断と一致した。
+</a:t>
             </a:r>
             <a:endParaRPr lang="en-US" sz="1400" dirty="0"/>
           </a:p>
-        </p:txBody>
-      </p:sp>
-      <p:sp>
-        <p:nvSpPr>
-          <p:cNvPr id="10" name="Text 8"/>
-          <p:cNvSpPr/>
-          <p:nvPr/>
-        </p:nvSpPr>
-        <p:spPr>
-          <a:xfrm>
-            <a:off x="1234440" y="2395728"/>
-            <a:ext cx="3931920" cy="365760"/>
-          </a:xfrm>
-          <a:prstGeom prst="rect">
-            <a:avLst/>
-          </a:prstGeom>
-          <a:noFill/>
-          <a:ln/>
-        </p:spPr>
-        <p:txBody>
-          <a:bodyPr wrap="square" lIns="0" tIns="0" rIns="0" bIns="0" rtlCol="0" anchor="ctr"/>
-          <a:lstStyle/>
           <a:p>
             <a:pPr indent="0" marL="0">
               <a:buNone/>
             </a:pPr>
             <a:r>
-              <a:rPr lang="en-US" sz="1500" b="1" dirty="0">
+              <a:rPr lang="en-US" sz="1200" dirty="0">
+                <a:solidFill>
+                  <a:srgbClr val="CADCFC"/>
+                </a:solidFill>
+                <a:latin typeface="Meiryo" pitchFamily="34" charset="0"/>
+                <a:ea typeface="Meiryo" pitchFamily="34" charset="-122"/>
+                <a:cs typeface="Meiryo" pitchFamily="34" charset="-120"/>
+              </a:rPr>
+              <a:t>機械学習の技法ではなく、対象への理解が精度を上げた事例。</a:t>
+            </a:r>
+            <a:endParaRPr lang="en-US" sz="1400" dirty="0"/>
+          </a:p>
+        </p:txBody>
+      </p:sp>
+      <p:sp>
+        <p:nvSpPr>
+          <p:cNvPr id="10" name="Shape 7"/>
+          <p:cNvSpPr/>
+          <p:nvPr/>
+        </p:nvSpPr>
+        <p:spPr>
+          <a:xfrm>
+            <a:off x="7772400" y="5257800"/>
+            <a:ext cx="3840480" cy="1051560"/>
+          </a:xfrm>
+          <a:prstGeom prst="roundRect">
+            <a:avLst>
+              <a:gd name="adj" fmla="val 6957"/>
+            </a:avLst>
+          </a:prstGeom>
+          <a:solidFill>
+            <a:srgbClr val="FDF1EE"/>
+          </a:solidFill>
+          <a:ln/>
+        </p:spPr>
+      </p:sp>
+      <p:sp>
+        <p:nvSpPr>
+          <p:cNvPr id="11" name="Text 8"/>
+          <p:cNvSpPr/>
+          <p:nvPr/>
+        </p:nvSpPr>
+        <p:spPr>
+          <a:xfrm>
+            <a:off x="7973568" y="5376672"/>
+            <a:ext cx="3474720" cy="868680"/>
+          </a:xfrm>
+          <a:prstGeom prst="rect">
+            <a:avLst/>
+          </a:prstGeom>
+          <a:noFill/>
+          <a:ln/>
+        </p:spPr>
+        <p:txBody>
+          <a:bodyPr wrap="square" lIns="0" tIns="0" rIns="0" bIns="0" rtlCol="0" anchor="ctr"/>
+          <a:lstStyle/>
+          <a:p>
+            <a:pPr indent="0" marL="0">
+              <a:buNone/>
+            </a:pPr>
+            <a:r>
+              <a:rPr lang="en-US" sz="1250" b="1" dirty="0">
+                <a:solidFill>
+                  <a:srgbClr val="B3341F"/>
+                </a:solidFill>
+                <a:latin typeface="Meiryo" pitchFamily="34" charset="0"/>
+                <a:ea typeface="Meiryo" pitchFamily="34" charset="-122"/>
+                <a:cs typeface="Meiryo" pitchFamily="34" charset="-120"/>
+              </a:rPr>
+              <a:t>要確認
+</a:t>
+            </a:r>
+            <a:endParaRPr lang="en-US" sz="1250" dirty="0"/>
+          </a:p>
+          <a:p>
+            <a:pPr indent="0" marL="0">
+              <a:buNone/>
+            </a:pPr>
+            <a:r>
+              <a:rPr lang="en-US" sz="1050" dirty="0">
                 <a:solidFill>
                   <a:srgbClr val="1A1A1A"/>
                 </a:solidFill>
@@ -8104,534 +10610,9 @@
                 <a:ea typeface="Meiryo" pitchFamily="34" charset="-122"/>
                 <a:cs typeface="Meiryo" pitchFamily="34" charset="-120"/>
               </a:rPr>
-              <a:t>ラベルの再現性の測定</a:t>
-            </a:r>
-            <a:endParaRPr lang="en-US" sz="1500" dirty="0"/>
-          </a:p>
-        </p:txBody>
-      </p:sp>
-      <p:sp>
-        <p:nvSpPr>
-          <p:cNvPr id="11" name="Text 9"/>
-          <p:cNvSpPr/>
-          <p:nvPr/>
-        </p:nvSpPr>
-        <p:spPr>
-          <a:xfrm>
-            <a:off x="5257800" y="2377440"/>
-            <a:ext cx="6309360" cy="566928"/>
-          </a:xfrm>
-          <a:prstGeom prst="rect">
-            <a:avLst/>
-          </a:prstGeom>
-          <a:noFill/>
-          <a:ln/>
-        </p:spPr>
-        <p:txBody>
-          <a:bodyPr wrap="square" lIns="0" tIns="0" rIns="0" bIns="0" rtlCol="0" anchor="ctr"/>
-          <a:lstStyle/>
-          <a:p>
-            <a:pPr indent="0" marL="0">
-              <a:buNone/>
-            </a:pPr>
-            <a:r>
-              <a:rPr lang="en-US" sz="1200" dirty="0">
-                <a:solidFill>
-                  <a:srgbClr val="5A6472"/>
-                </a:solidFill>
-                <a:latin typeface="Meiryo" pitchFamily="34" charset="0"/>
-                <a:ea typeface="Meiryo" pitchFamily="34" charset="-122"/>
-                <a:cs typeface="Meiryo" pitchFamily="34" charset="-120"/>
-              </a:rPr>
-              <a:t>同じ天気図に答えを見ずに再度ラベル付けし、人間の判断のゆらぎを測る。これが達成可能な性能の上限になる。</a:t>
-            </a:r>
-            <a:endParaRPr lang="en-US" sz="1200" dirty="0"/>
-          </a:p>
-        </p:txBody>
-      </p:sp>
-      <p:sp>
-        <p:nvSpPr>
-          <p:cNvPr id="12" name="Shape 10"/>
-          <p:cNvSpPr/>
-          <p:nvPr/>
-        </p:nvSpPr>
-        <p:spPr>
-          <a:xfrm>
-            <a:off x="640080" y="3227832"/>
-            <a:ext cx="402336" cy="402336"/>
-          </a:xfrm>
-          <a:prstGeom prst="ellipse">
-            <a:avLst/>
-          </a:prstGeom>
-          <a:solidFill>
-            <a:srgbClr val="065A82"/>
-          </a:solidFill>
-          <a:ln/>
-        </p:spPr>
-      </p:sp>
-      <p:sp>
-        <p:nvSpPr>
-          <p:cNvPr id="13" name="Text 11"/>
-          <p:cNvSpPr/>
-          <p:nvPr/>
-        </p:nvSpPr>
-        <p:spPr>
-          <a:xfrm>
-            <a:off x="640080" y="3273552"/>
-            <a:ext cx="402336" cy="310896"/>
-          </a:xfrm>
-          <a:prstGeom prst="rect">
-            <a:avLst/>
-          </a:prstGeom>
-          <a:noFill/>
-          <a:ln/>
-        </p:spPr>
-        <p:txBody>
-          <a:bodyPr wrap="square" lIns="0" tIns="0" rIns="0" bIns="0" rtlCol="0" anchor="ctr"/>
-          <a:lstStyle/>
-          <a:p>
-            <a:pPr algn="ctr" indent="0" marL="0">
-              <a:buNone/>
-            </a:pPr>
-            <a:r>
-              <a:rPr lang="en-US" sz="1400" b="1" dirty="0">
-                <a:solidFill>
-                  <a:srgbClr val="FFFFFF"/>
-                </a:solidFill>
-                <a:latin typeface="Cambria" pitchFamily="34" charset="0"/>
-                <a:ea typeface="Cambria" pitchFamily="34" charset="-122"/>
-                <a:cs typeface="Cambria" pitchFamily="34" charset="-120"/>
-              </a:rPr>
-              <a:t>3</a:t>
-            </a:r>
-            <a:endParaRPr lang="en-US" sz="1400" dirty="0"/>
-          </a:p>
-        </p:txBody>
-      </p:sp>
-      <p:sp>
-        <p:nvSpPr>
-          <p:cNvPr id="14" name="Text 12"/>
-          <p:cNvSpPr/>
-          <p:nvPr/>
-        </p:nvSpPr>
-        <p:spPr>
-          <a:xfrm>
-            <a:off x="1234440" y="3191256"/>
-            <a:ext cx="3931920" cy="365760"/>
-          </a:xfrm>
-          <a:prstGeom prst="rect">
-            <a:avLst/>
-          </a:prstGeom>
-          <a:noFill/>
-          <a:ln/>
-        </p:spPr>
-        <p:txBody>
-          <a:bodyPr wrap="square" lIns="0" tIns="0" rIns="0" bIns="0" rtlCol="0" anchor="ctr"/>
-          <a:lstStyle/>
-          <a:p>
-            <a:pPr indent="0" marL="0">
-              <a:buNone/>
-            </a:pPr>
-            <a:r>
-              <a:rPr lang="en-US" sz="1500" b="1" dirty="0">
-                <a:solidFill>
-                  <a:srgbClr val="1A1A1A"/>
-                </a:solidFill>
-                <a:latin typeface="Meiryo" pitchFamily="34" charset="0"/>
-                <a:ea typeface="Meiryo" pitchFamily="34" charset="-122"/>
-                <a:cs typeface="Meiryo" pitchFamily="34" charset="-120"/>
-              </a:rPr>
-              <a:t>乱数シードを変えた再現確認</a:t>
-            </a:r>
-            <a:endParaRPr lang="en-US" sz="1500" dirty="0"/>
-          </a:p>
-        </p:txBody>
-      </p:sp>
-      <p:sp>
-        <p:nvSpPr>
-          <p:cNvPr id="15" name="Text 13"/>
-          <p:cNvSpPr/>
-          <p:nvPr/>
-        </p:nvSpPr>
-        <p:spPr>
-          <a:xfrm>
-            <a:off x="5257800" y="3172968"/>
-            <a:ext cx="6309360" cy="566928"/>
-          </a:xfrm>
-          <a:prstGeom prst="rect">
-            <a:avLst/>
-          </a:prstGeom>
-          <a:noFill/>
-          <a:ln/>
-        </p:spPr>
-        <p:txBody>
-          <a:bodyPr wrap="square" lIns="0" tIns="0" rIns="0" bIns="0" rtlCol="0" anchor="ctr"/>
-          <a:lstStyle/>
-          <a:p>
-            <a:pPr indent="0" marL="0">
-              <a:buNone/>
-            </a:pPr>
-            <a:r>
-              <a:rPr lang="en-US" sz="1200" dirty="0">
-                <a:solidFill>
-                  <a:srgbClr val="5A6472"/>
-                </a:solidFill>
-                <a:latin typeface="Meiryo" pitchFamily="34" charset="0"/>
-                <a:ea typeface="Meiryo" pitchFamily="34" charset="-122"/>
-                <a:cs typeface="Meiryo" pitchFamily="34" charset="-120"/>
-              </a:rPr>
-              <a:t>現在の +0.017 という改善は1条件のみの結果。複数回繰り返して安定性を確認する。</a:t>
-            </a:r>
-            <a:endParaRPr lang="en-US" sz="1200" dirty="0"/>
-          </a:p>
-        </p:txBody>
-      </p:sp>
-      <p:sp>
-        <p:nvSpPr>
-          <p:cNvPr id="16" name="Shape 14"/>
-          <p:cNvSpPr/>
-          <p:nvPr/>
-        </p:nvSpPr>
-        <p:spPr>
-          <a:xfrm>
-            <a:off x="640080" y="4023360"/>
-            <a:ext cx="402336" cy="402336"/>
-          </a:xfrm>
-          <a:prstGeom prst="ellipse">
-            <a:avLst/>
-          </a:prstGeom>
-          <a:solidFill>
-            <a:srgbClr val="065A82"/>
-          </a:solidFill>
-          <a:ln/>
-        </p:spPr>
-      </p:sp>
-      <p:sp>
-        <p:nvSpPr>
-          <p:cNvPr id="17" name="Text 15"/>
-          <p:cNvSpPr/>
-          <p:nvPr/>
-        </p:nvSpPr>
-        <p:spPr>
-          <a:xfrm>
-            <a:off x="640080" y="4069080"/>
-            <a:ext cx="402336" cy="310896"/>
-          </a:xfrm>
-          <a:prstGeom prst="rect">
-            <a:avLst/>
-          </a:prstGeom>
-          <a:noFill/>
-          <a:ln/>
-        </p:spPr>
-        <p:txBody>
-          <a:bodyPr wrap="square" lIns="0" tIns="0" rIns="0" bIns="0" rtlCol="0" anchor="ctr"/>
-          <a:lstStyle/>
-          <a:p>
-            <a:pPr algn="ctr" indent="0" marL="0">
-              <a:buNone/>
-            </a:pPr>
-            <a:r>
-              <a:rPr lang="en-US" sz="1400" b="1" dirty="0">
-                <a:solidFill>
-                  <a:srgbClr val="FFFFFF"/>
-                </a:solidFill>
-                <a:latin typeface="Cambria" pitchFamily="34" charset="0"/>
-                <a:ea typeface="Cambria" pitchFamily="34" charset="-122"/>
-                <a:cs typeface="Cambria" pitchFamily="34" charset="-120"/>
-              </a:rPr>
-              <a:t>4</a:t>
-            </a:r>
-            <a:endParaRPr lang="en-US" sz="1400" dirty="0"/>
-          </a:p>
-        </p:txBody>
-      </p:sp>
-      <p:sp>
-        <p:nvSpPr>
-          <p:cNvPr id="18" name="Text 16"/>
-          <p:cNvSpPr/>
-          <p:nvPr/>
-        </p:nvSpPr>
-        <p:spPr>
-          <a:xfrm>
-            <a:off x="1234440" y="3986784"/>
-            <a:ext cx="3931920" cy="365760"/>
-          </a:xfrm>
-          <a:prstGeom prst="rect">
-            <a:avLst/>
-          </a:prstGeom>
-          <a:noFill/>
-          <a:ln/>
-        </p:spPr>
-        <p:txBody>
-          <a:bodyPr wrap="square" lIns="0" tIns="0" rIns="0" bIns="0" rtlCol="0" anchor="ctr"/>
-          <a:lstStyle/>
-          <a:p>
-            <a:pPr indent="0" marL="0">
-              <a:buNone/>
-            </a:pPr>
-            <a:r>
-              <a:rPr lang="en-US" sz="1500" b="1" dirty="0">
-                <a:solidFill>
-                  <a:srgbClr val="1A1A1A"/>
-                </a:solidFill>
-                <a:latin typeface="Meiryo" pitchFamily="34" charset="0"/>
-                <a:ea typeface="Meiryo" pitchFamily="34" charset="-122"/>
-                <a:cs typeface="Meiryo" pitchFamily="34" charset="-120"/>
-              </a:rPr>
-              <a:t>確信度の較正</a:t>
-            </a:r>
-            <a:endParaRPr lang="en-US" sz="1500" dirty="0"/>
-          </a:p>
-        </p:txBody>
-      </p:sp>
-      <p:sp>
-        <p:nvSpPr>
-          <p:cNvPr id="19" name="Text 17"/>
-          <p:cNvSpPr/>
-          <p:nvPr/>
-        </p:nvSpPr>
-        <p:spPr>
-          <a:xfrm>
-            <a:off x="5257800" y="3968496"/>
-            <a:ext cx="6309360" cy="566928"/>
-          </a:xfrm>
-          <a:prstGeom prst="rect">
-            <a:avLst/>
-          </a:prstGeom>
-          <a:noFill/>
-          <a:ln/>
-        </p:spPr>
-        <p:txBody>
-          <a:bodyPr wrap="square" lIns="0" tIns="0" rIns="0" bIns="0" rtlCol="0" anchor="ctr"/>
-          <a:lstStyle/>
-          <a:p>
-            <a:pPr indent="0" marL="0">
-              <a:buNone/>
-            </a:pPr>
-            <a:r>
-              <a:rPr lang="en-US" sz="1200" dirty="0">
-                <a:solidFill>
-                  <a:srgbClr val="5A6472"/>
-                </a:solidFill>
-                <a:latin typeface="Meiryo" pitchFamily="34" charset="0"/>
-                <a:ea typeface="Meiryo" pitchFamily="34" charset="-122"/>
-                <a:cs typeface="Meiryo" pitchFamily="34" charset="-120"/>
-              </a:rPr>
-              <a:t>確信度の中央値0.977に対し実際の性能は0.613。自信過剰であり、補正が必要。</a:t>
-            </a:r>
-            <a:endParaRPr lang="en-US" sz="1200" dirty="0"/>
-          </a:p>
-        </p:txBody>
-      </p:sp>
-      <p:sp>
-        <p:nvSpPr>
-          <p:cNvPr id="20" name="Shape 18"/>
-          <p:cNvSpPr/>
-          <p:nvPr/>
-        </p:nvSpPr>
-        <p:spPr>
-          <a:xfrm>
-            <a:off x="640080" y="4818888"/>
-            <a:ext cx="402336" cy="402336"/>
-          </a:xfrm>
-          <a:prstGeom prst="ellipse">
-            <a:avLst/>
-          </a:prstGeom>
-          <a:solidFill>
-            <a:srgbClr val="1C7293"/>
-          </a:solidFill>
-          <a:ln/>
-        </p:spPr>
-      </p:sp>
-      <p:sp>
-        <p:nvSpPr>
-          <p:cNvPr id="21" name="Text 19"/>
-          <p:cNvSpPr/>
-          <p:nvPr/>
-        </p:nvSpPr>
-        <p:spPr>
-          <a:xfrm>
-            <a:off x="640080" y="4864608"/>
-            <a:ext cx="402336" cy="310896"/>
-          </a:xfrm>
-          <a:prstGeom prst="rect">
-            <a:avLst/>
-          </a:prstGeom>
-          <a:noFill/>
-          <a:ln/>
-        </p:spPr>
-        <p:txBody>
-          <a:bodyPr wrap="square" lIns="0" tIns="0" rIns="0" bIns="0" rtlCol="0" anchor="ctr"/>
-          <a:lstStyle/>
-          <a:p>
-            <a:pPr algn="ctr" indent="0" marL="0">
-              <a:buNone/>
-            </a:pPr>
-            <a:r>
-              <a:rPr lang="en-US" sz="1400" b="1" dirty="0">
-                <a:solidFill>
-                  <a:srgbClr val="FFFFFF"/>
-                </a:solidFill>
-                <a:latin typeface="Cambria" pitchFamily="34" charset="0"/>
-                <a:ea typeface="Cambria" pitchFamily="34" charset="-122"/>
-                <a:cs typeface="Cambria" pitchFamily="34" charset="-120"/>
-              </a:rPr>
-              <a:t>5</a:t>
-            </a:r>
-            <a:endParaRPr lang="en-US" sz="1400" dirty="0"/>
-          </a:p>
-        </p:txBody>
-      </p:sp>
-      <p:sp>
-        <p:nvSpPr>
-          <p:cNvPr id="22" name="Text 20"/>
-          <p:cNvSpPr/>
-          <p:nvPr/>
-        </p:nvSpPr>
-        <p:spPr>
-          <a:xfrm>
-            <a:off x="1234440" y="4782312"/>
-            <a:ext cx="3931920" cy="365760"/>
-          </a:xfrm>
-          <a:prstGeom prst="rect">
-            <a:avLst/>
-          </a:prstGeom>
-          <a:noFill/>
-          <a:ln/>
-        </p:spPr>
-        <p:txBody>
-          <a:bodyPr wrap="square" lIns="0" tIns="0" rIns="0" bIns="0" rtlCol="0" anchor="ctr"/>
-          <a:lstStyle/>
-          <a:p>
-            <a:pPr indent="0" marL="0">
-              <a:buNone/>
-            </a:pPr>
-            <a:r>
-              <a:rPr lang="en-US" sz="1500" b="1" dirty="0">
-                <a:solidFill>
-                  <a:srgbClr val="1A1A1A"/>
-                </a:solidFill>
-                <a:latin typeface="Meiryo" pitchFamily="34" charset="0"/>
-                <a:ea typeface="Meiryo" pitchFamily="34" charset="-122"/>
-                <a:cs typeface="Meiryo" pitchFamily="34" charset="-120"/>
-              </a:rPr>
-              <a:t>時間方向の情報の利用</a:t>
-            </a:r>
-            <a:endParaRPr lang="en-US" sz="1500" dirty="0"/>
-          </a:p>
-        </p:txBody>
-      </p:sp>
-      <p:sp>
-        <p:nvSpPr>
-          <p:cNvPr id="23" name="Text 21"/>
-          <p:cNvSpPr/>
-          <p:nvPr/>
-        </p:nvSpPr>
-        <p:spPr>
-          <a:xfrm>
-            <a:off x="5257800" y="4764024"/>
-            <a:ext cx="6309360" cy="566928"/>
-          </a:xfrm>
-          <a:prstGeom prst="rect">
-            <a:avLst/>
-          </a:prstGeom>
-          <a:noFill/>
-          <a:ln/>
-        </p:spPr>
-        <p:txBody>
-          <a:bodyPr wrap="square" lIns="0" tIns="0" rIns="0" bIns="0" rtlCol="0" anchor="ctr"/>
-          <a:lstStyle/>
-          <a:p>
-            <a:pPr indent="0" marL="0">
-              <a:buNone/>
-            </a:pPr>
-            <a:r>
-              <a:rPr lang="en-US" sz="1200" dirty="0">
-                <a:solidFill>
-                  <a:srgbClr val="5A6472"/>
-                </a:solidFill>
-                <a:latin typeface="Meiryo" pitchFamily="34" charset="0"/>
-                <a:ea typeface="Meiryo" pitchFamily="34" charset="-122"/>
-                <a:cs typeface="Meiryo" pitchFamily="34" charset="-120"/>
-              </a:rPr>
-              <a:t>「前線通過」「停滞」は単一時刻では原理的に判別できない。複数時刻の入力が必要。</a:t>
-            </a:r>
-            <a:endParaRPr lang="en-US" sz="1200" dirty="0"/>
-          </a:p>
-        </p:txBody>
-      </p:sp>
-      <p:sp>
-        <p:nvSpPr>
-          <p:cNvPr id="24" name="Shape 22"/>
-          <p:cNvSpPr/>
-          <p:nvPr/>
-        </p:nvSpPr>
-        <p:spPr>
-          <a:xfrm>
-            <a:off x="640080" y="5623560"/>
-            <a:ext cx="10972800" cy="868680"/>
-          </a:xfrm>
-          <a:prstGeom prst="roundRect">
-            <a:avLst>
-              <a:gd name="adj" fmla="val 8421"/>
-            </a:avLst>
-          </a:prstGeom>
-          <a:solidFill>
-            <a:srgbClr val="F4F7F9"/>
-          </a:solidFill>
-          <a:ln/>
-        </p:spPr>
-      </p:sp>
-      <p:sp>
-        <p:nvSpPr>
-          <p:cNvPr id="25" name="Text 23"/>
-          <p:cNvSpPr/>
-          <p:nvPr/>
-        </p:nvSpPr>
-        <p:spPr>
-          <a:xfrm>
-            <a:off x="914400" y="5833872"/>
-            <a:ext cx="10424160" cy="457200"/>
-          </a:xfrm>
-          <a:prstGeom prst="rect">
-            <a:avLst/>
-          </a:prstGeom>
-          <a:noFill/>
-          <a:ln/>
-        </p:spPr>
-        <p:txBody>
-          <a:bodyPr wrap="square" lIns="0" tIns="0" rIns="0" bIns="0" rtlCol="0" anchor="ctr"/>
-          <a:lstStyle/>
-          <a:p>
-            <a:pPr indent="0" marL="0">
-              <a:buNone/>
-            </a:pPr>
-            <a:r>
-              <a:rPr lang="en-US" sz="1350" b="1" dirty="0">
-                <a:solidFill>
-                  <a:srgbClr val="B3341F"/>
-                </a:solidFill>
-                <a:latin typeface="Meiryo" pitchFamily="34" charset="0"/>
-                <a:ea typeface="Meiryo" pitchFamily="34" charset="-122"/>
-                <a:cs typeface="Meiryo" pitchFamily="34" charset="-120"/>
-              </a:rPr>
-              <a:t>優先度が最も高いのは 2 。</a:t>
-            </a:r>
-            <a:pPr indent="0" marL="0">
-              <a:buNone/>
-            </a:pPr>
-            <a:r>
-              <a:rPr lang="en-US" sz="1250" dirty="0">
-                <a:solidFill>
-                  <a:srgbClr val="1A1A1A"/>
-                </a:solidFill>
-                <a:latin typeface="Meiryo" pitchFamily="34" charset="0"/>
-                <a:ea typeface="Meiryo" pitchFamily="34" charset="-122"/>
-                <a:cs typeface="Meiryo" pitchFamily="34" charset="-120"/>
-              </a:rPr>
-              <a:t>　人間の一致率が分からなければ、0.63 という数値が良いのか悪いのかを判断できない。</a:t>
-            </a:r>
-            <a:endParaRPr lang="en-US" sz="1350" dirty="0"/>
+              <a:t>850hPa気温も単独AUC 0.792。暖候期に偏るラベルのため、季節を当てているだけの可能性がある。</a:t>
+            </a:r>
+            <a:endParaRPr lang="en-US" sz="1250" dirty="0"/>
           </a:p>
         </p:txBody>
       </p:sp>

</xml_diff>

<commit_message>
Record the seasonal control result on the ERA5 slide
Restricting the check to May-August holds season roughly fixed. The derived
easterly keeps AUC 0.807 exactly and the southern pressure anomaly 0.812, so
both read the pattern rather than the calendar; 850 hPa temperature falls from
0.792 to 0.575, which settles what it was doing. The slide said "needs
checking" — now it says what the check found.

Co-Authored-By: Claude Opus 5 <noreply@anthropic.com>
Claude-Session: https://claude.ai/code/session_019nnTfL7acNUTjGfLDvFms9
</commit_message>
<xml_diff>
--- a/reports/進捗報告.pptx
+++ b/reports/進捗報告.pptx
@@ -1725,7 +1725,7 @@
           <a:p>
             <a:r>
               <a:rPr lang="en-US" dirty="0"/>
-              <a:t>ラベルは北東気流が入りそうかという予報官の判断で付けられている。高気圧が海の南部にあるほど入りやすいという知見を、領域の分割と地衡風の計算という形で特徴量にした。単独AUCでも係数でも南が北を上回り、風の係数の符号も判断と一致した。</a:t>
+              <a:t>ラベルは北東気流が入りそうかという予報官の判断で付けられている。高気圧が海の南部にあるほど入りやすいという知見を、領域の分割と地衡風の計算という形で特徴量にした。単独AUCでも係数でも南が北を上回り、風の係数の符号も判断と一致した。さらに5から8月に限って測り直し、季節を当てているだけではないことを確認している。850hPa気温だけは季節の代理だった。</a:t>
             </a:r>
             <a:endParaRPr lang="en-US" dirty="0"/>
           </a:p>
@@ -10505,7 +10505,7 @@
               <a:buNone/>
             </a:pPr>
             <a:r>
-              <a:rPr lang="en-US" sz="1400" b="1" dirty="0">
+              <a:rPr lang="en-US" sz="1350" b="1" dirty="0">
                 <a:solidFill>
                   <a:srgbClr val="FFFFFF"/>
                 </a:solidFill>
@@ -10513,10 +10513,10 @@
                 <a:ea typeface="Meiryo" pitchFamily="34" charset="-122"/>
                 <a:cs typeface="Meiryo" pitchFamily="34" charset="-120"/>
               </a:rPr>
-              <a:t>符号まで予報官の判断と一致した。
+              <a:t>符号まで予報官の判断と一致し、季節を固定しても消えない。
 </a:t>
             </a:r>
-            <a:endParaRPr lang="en-US" sz="1400" dirty="0"/>
+            <a:endParaRPr lang="en-US" sz="1350" dirty="0"/>
           </a:p>
           <a:p>
             <a:pPr indent="0" marL="0">
@@ -10533,7 +10533,7 @@
               </a:rPr>
               <a:t>機械学習の技法ではなく、対象への理解が精度を上げた事例。</a:t>
             </a:r>
-            <a:endParaRPr lang="en-US" sz="1400" dirty="0"/>
+            <a:endParaRPr lang="en-US" sz="1350" dirty="0"/>
           </a:p>
         </p:txBody>
       </p:sp>
@@ -10554,7 +10554,7 @@
             </a:avLst>
           </a:prstGeom>
           <a:solidFill>
-            <a:srgbClr val="FDF1EE"/>
+            <a:srgbClr val="F4F7F9"/>
           </a:solidFill>
           <a:ln/>
         </p:spPr>
@@ -10586,13 +10586,13 @@
             <a:r>
               <a:rPr lang="en-US" sz="1250" b="1" dirty="0">
                 <a:solidFill>
-                  <a:srgbClr val="B3341F"/>
+                  <a:srgbClr val="1C7293"/>
                 </a:solidFill>
                 <a:latin typeface="Meiryo" pitchFamily="34" charset="0"/>
                 <a:ea typeface="Meiryo" pitchFamily="34" charset="-122"/>
                 <a:cs typeface="Meiryo" pitchFamily="34" charset="-120"/>
               </a:rPr>
-              <a:t>要確認
+              <a:t>季節の影響は確認済み
 </a:t>
             </a:r>
             <a:endParaRPr lang="en-US" sz="1250" dirty="0"/>
@@ -10602,7 +10602,7 @@
               <a:buNone/>
             </a:pPr>
             <a:r>
-              <a:rPr lang="en-US" sz="1050" dirty="0">
+              <a:rPr lang="en-US" sz="1000" dirty="0">
                 <a:solidFill>
                   <a:srgbClr val="1A1A1A"/>
                 </a:solidFill>
@@ -10610,7 +10610,7 @@
                 <a:ea typeface="Meiryo" pitchFamily="34" charset="-122"/>
                 <a:cs typeface="Meiryo" pitchFamily="34" charset="-120"/>
               </a:rPr>
-              <a:t>850hPa気温も単独AUC 0.792。暖候期に偏るラベルのため、季節を当てているだけの可能性がある。</a:t>
+              <a:t>5〜8月に限って測り直しても、風は0.807で不変、南部の気圧は0.812を維持。一方850hPa気温は0.792→0.575に崩れ、季節の代理だったと判明。</a:t>
             </a:r>
             <a:endParaRPr lang="en-US" sz="1250" dirty="0"/>
           </a:p>

</xml_diff>